<commit_message>
small fix slides pv-hoare
</commit_message>
<xml_diff>
--- a/slides/PV_hoare.pptx
+++ b/slides/PV_hoare.pptx
@@ -250,8 +250,7 @@
 <file path=ppt/revisionInfo.xml><?xml version="1.0" encoding="utf-8"?>
 <p1510:revInfo xmlns:a="http://schemas.openxmlformats.org/drawingml/2006/main" xmlns:r="http://schemas.openxmlformats.org/officeDocument/2006/relationships" xmlns:p1510="http://schemas.microsoft.com/office/powerpoint/2015/10/main">
   <p1510:revLst>
-    <p1510:client id="{0C54D34E-4B66-8376-A495-8F965818422D}" v="6" dt="2026-09-09T07:15:27.013"/>
-    <p1510:client id="{B7276C23-DA95-681E-6777-86D714534B61}" v="212" dt="2026-09-09T09:37:19.068"/>
+    <p1510:client id="{20A9E591-45A4-288A-4724-26405B23B450}" v="6" dt="2026-09-14T14:05:59.952"/>
   </p1510:revLst>
 </p1510:revInfo>
 </file>
@@ -277,6 +276,30 @@
             <pc:docMk/>
             <pc:sldMk cId="0" sldId="304"/>
             <ac:spMk id="7" creationId="{00000000-0000-0000-0000-000000000000}"/>
+          </ac:spMkLst>
+        </pc:spChg>
+      </pc:sldChg>
+    </pc:docChg>
+  </pc:docChgLst>
+  <pc:docChgLst>
+    <pc:chgData name="Prasetya, S.W.B. (Wishnu)" userId="S::s.w.b.prasetya@uu.nl::ee0482cf-91c5-406c-9af5-c23fbce206d6" providerId="AD" clId="Web-{20A9E591-45A4-288A-4724-26405B23B450}"/>
+    <pc:docChg chg="modSld">
+      <pc:chgData name="Prasetya, S.W.B. (Wishnu)" userId="S::s.w.b.prasetya@uu.nl::ee0482cf-91c5-406c-9af5-c23fbce206d6" providerId="AD" clId="Web-{20A9E591-45A4-288A-4724-26405B23B450}" dt="2026-09-14T14:05:56.561" v="4" actId="20577"/>
+      <pc:docMkLst>
+        <pc:docMk/>
+      </pc:docMkLst>
+      <pc:sldChg chg="modSp">
+        <pc:chgData name="Prasetya, S.W.B. (Wishnu)" userId="S::s.w.b.prasetya@uu.nl::ee0482cf-91c5-406c-9af5-c23fbce206d6" providerId="AD" clId="Web-{20A9E591-45A4-288A-4724-26405B23B450}" dt="2026-09-14T14:05:56.561" v="4" actId="20577"/>
+        <pc:sldMkLst>
+          <pc:docMk/>
+          <pc:sldMk cId="2453779464" sldId="374"/>
+        </pc:sldMkLst>
+        <pc:spChg chg="mod">
+          <ac:chgData name="Prasetya, S.W.B. (Wishnu)" userId="S::s.w.b.prasetya@uu.nl::ee0482cf-91c5-406c-9af5-c23fbce206d6" providerId="AD" clId="Web-{20A9E591-45A4-288A-4724-26405B23B450}" dt="2026-09-14T14:05:56.561" v="4" actId="20577"/>
+          <ac:spMkLst>
+            <pc:docMk/>
+            <pc:sldMk cId="2453779464" sldId="374"/>
+            <ac:spMk id="3" creationId="{1BEBF33D-AB78-9046-B42E-8AFC3B5D70BF}"/>
           </ac:spMkLst>
         </pc:spChg>
       </pc:sldChg>
@@ -19515,7 +19538,7 @@
           </a:xfrm>
         </p:spPr>
         <p:txBody>
-          <a:bodyPr>
+          <a:bodyPr vert="horz" lIns="91440" tIns="45720" rIns="91440" bIns="45720" rtlCol="0" anchor="t">
             <a:noAutofit/>
           </a:bodyPr>
           <a:lstStyle/>
@@ -19580,7 +19603,7 @@
             <a:pPr lvl="1"/>
             <a:r>
               <a:rPr lang="en-US" sz="2400" dirty="0"/>
-              <a:t>Condition h is unsatisfiable if C</a:t>
+              <a:t>Condition h is unfeasible if C</a:t>
             </a:r>
             <a:r>
               <a:rPr lang="en-US" sz="2400" baseline="-25000" dirty="0"/>

</xml_diff>

<commit_message>
updating slides Hoare logic
</commit_message>
<xml_diff>
--- a/slides/PV_hoare.pptx
+++ b/slides/PV_hoare.pptx
@@ -5,7 +5,7 @@
     <p:sldMasterId id="2147484083" r:id="rId1"/>
   </p:sldMasterIdLst>
   <p:notesMasterIdLst>
-    <p:notesMasterId r:id="rId74"/>
+    <p:notesMasterId r:id="rId72"/>
   </p:notesMasterIdLst>
   <p:sldIdLst>
     <p:sldId id="256" r:id="rId2"/>
@@ -71,15 +71,13 @@
     <p:sldId id="379" r:id="rId62"/>
     <p:sldId id="345" r:id="rId63"/>
     <p:sldId id="329" r:id="rId64"/>
-    <p:sldId id="357" r:id="rId65"/>
-    <p:sldId id="358" r:id="rId66"/>
-    <p:sldId id="359" r:id="rId67"/>
-    <p:sldId id="360" r:id="rId68"/>
-    <p:sldId id="365" r:id="rId69"/>
-    <p:sldId id="361" r:id="rId70"/>
-    <p:sldId id="370" r:id="rId71"/>
-    <p:sldId id="380" r:id="rId72"/>
-    <p:sldId id="352" r:id="rId73"/>
+    <p:sldId id="387" r:id="rId65"/>
+    <p:sldId id="360" r:id="rId66"/>
+    <p:sldId id="365" r:id="rId67"/>
+    <p:sldId id="357" r:id="rId68"/>
+    <p:sldId id="370" r:id="rId69"/>
+    <p:sldId id="389" r:id="rId70"/>
+    <p:sldId id="352" r:id="rId71"/>
   </p:sldIdLst>
   <p:sldSz cx="9144000" cy="6858000" type="screen4x3"/>
   <p:notesSz cx="6858000" cy="9144000"/>
@@ -405,16 +403,6 @@
 </p:cmLst>
 </file>
 
-<file path=ppt/comments/comment4.xml><?xml version="1.0" encoding="utf-8"?>
-<p:cmLst xmlns:a="http://schemas.openxmlformats.org/drawingml/2006/main" xmlns:r="http://schemas.openxmlformats.org/officeDocument/2006/relationships" xmlns:p="http://schemas.openxmlformats.org/presentationml/2006/main">
-  <p:cm authorId="0" dt="2014-02-13T15:30:26.735" idx="5">
-    <p:pos x="178" y="1666"/>
-    <p:text>This disjunction is ok; see the example in the notes.
-Alternatively, use conjunction, but turn the ~exp and exc conjunct in the post-cond into implication.</p:text>
-  </p:cm>
-</p:cmLst>
-</file>
-
 <file path=ppt/notesMasters/notesMaster1.xml><?xml version="1.0" encoding="utf-8"?>
 <p:notesMaster xmlns:a="http://schemas.openxmlformats.org/drawingml/2006/main" xmlns:r="http://schemas.openxmlformats.org/officeDocument/2006/relationships" xmlns:p="http://schemas.openxmlformats.org/presentationml/2006/main">
   <p:cSld>
@@ -4700,7 +4688,7 @@
         <p:spPr/>
         <p:txBody>
           <a:bodyPr>
-            <a:normAutofit fontScale="70000" lnSpcReduction="20000"/>
+            <a:normAutofit fontScale="47500" lnSpcReduction="20000"/>
           </a:bodyPr>
           <a:lstStyle/>
           <a:p>
@@ -7599,7 +7587,7 @@
               <a:pPr>
                 <a:defRPr/>
               </a:pPr>
-              <a:t>64</a:t>
+              <a:t>67</a:t>
             </a:fld>
             <a:endParaRPr lang="en-US"/>
           </a:p>
@@ -7609,662 +7597,6 @@
     <p:extLst>
       <p:ext uri="{BB962C8B-B14F-4D97-AF65-F5344CB8AC3E}">
         <p14:creationId xmlns:p14="http://schemas.microsoft.com/office/powerpoint/2010/main" val="578913574"/>
-      </p:ext>
-    </p:extLst>
-  </p:cSld>
-  <p:clrMapOvr>
-    <a:masterClrMapping/>
-  </p:clrMapOvr>
-</p:notes>
-</file>
-
-<file path=ppt/notesSlides/notesSlide48.xml><?xml version="1.0" encoding="utf-8"?>
-<p:notes xmlns:a="http://schemas.openxmlformats.org/drawingml/2006/main" xmlns:r="http://schemas.openxmlformats.org/officeDocument/2006/relationships" xmlns:p="http://schemas.openxmlformats.org/presentationml/2006/main">
-  <p:cSld>
-    <p:spTree>
-      <p:nvGrpSpPr>
-        <p:cNvPr id="1" name=""/>
-        <p:cNvGrpSpPr/>
-        <p:nvPr/>
-      </p:nvGrpSpPr>
-      <p:grpSpPr>
-        <a:xfrm>
-          <a:off x="0" y="0"/>
-          <a:ext cx="0" cy="0"/>
-          <a:chOff x="0" y="0"/>
-          <a:chExt cx="0" cy="0"/>
-        </a:xfrm>
-      </p:grpSpPr>
-      <p:sp>
-        <p:nvSpPr>
-          <p:cNvPr id="2" name="Slide Image Placeholder 1"/>
-          <p:cNvSpPr>
-            <a:spLocks noGrp="1" noRot="1" noChangeAspect="1"/>
-          </p:cNvSpPr>
-          <p:nvPr>
-            <p:ph type="sldImg"/>
-          </p:nvPr>
-        </p:nvSpPr>
-        <p:spPr/>
-      </p:sp>
-      <p:sp>
-        <p:nvSpPr>
-          <p:cNvPr id="3" name="Notes Placeholder 2"/>
-          <p:cNvSpPr>
-            <a:spLocks noGrp="1"/>
-          </p:cNvSpPr>
-          <p:nvPr>
-            <p:ph type="body" idx="1"/>
-          </p:nvPr>
-        </p:nvSpPr>
-        <p:spPr/>
-        <p:txBody>
-          <a:bodyPr>
-            <a:normAutofit/>
-          </a:bodyPr>
-          <a:lstStyle/>
-          <a:p>
-            <a:r>
-              <a:rPr lang="en-US" dirty="0"/>
-              <a:t>examples:</a:t>
-            </a:r>
-          </a:p>
-          <a:p>
-            <a:endParaRPr lang="en-US" dirty="0"/>
-          </a:p>
-          <a:p>
-            <a:r>
-              <a:rPr lang="en-US" dirty="0"/>
-              <a:t>(1) </a:t>
-            </a:r>
-          </a:p>
-          <a:p>
-            <a:r>
-              <a:rPr lang="en-US" dirty="0" err="1"/>
-              <a:t>wlp</a:t>
-            </a:r>
-            <a:r>
-              <a:rPr lang="en-US" baseline="0" dirty="0"/>
-              <a:t> skip ; skip  (x=0) </a:t>
-            </a:r>
-          </a:p>
-          <a:p>
-            <a:r>
-              <a:rPr lang="en-US" baseline="0" dirty="0"/>
-              <a:t>   =</a:t>
-            </a:r>
-          </a:p>
-          <a:p>
-            <a:r>
-              <a:rPr lang="en-US" dirty="0"/>
-              <a:t>  </a:t>
-            </a:r>
-            <a:r>
-              <a:rPr lang="en-US" dirty="0" err="1"/>
-              <a:t>wlp</a:t>
-            </a:r>
-            <a:r>
-              <a:rPr lang="en-US" baseline="0" dirty="0"/>
-              <a:t> skip (</a:t>
-            </a:r>
-            <a:r>
-              <a:rPr lang="en-US" baseline="0" dirty="0" err="1"/>
-              <a:t>exc</a:t>
-            </a:r>
-            <a:r>
-              <a:rPr lang="en-US" baseline="0" dirty="0"/>
-              <a:t> /\ x=0)</a:t>
-            </a:r>
-          </a:p>
-          <a:p>
-            <a:r>
-              <a:rPr lang="en-US" baseline="0" dirty="0"/>
-              <a:t>  \/</a:t>
-            </a:r>
-          </a:p>
-          <a:p>
-            <a:r>
-              <a:rPr lang="en-US" baseline="0" dirty="0"/>
-              <a:t>  </a:t>
-            </a:r>
-            <a:r>
-              <a:rPr lang="en-US" baseline="0" dirty="0" err="1"/>
-              <a:t>wlp</a:t>
-            </a:r>
-            <a:r>
-              <a:rPr lang="en-US" baseline="0" dirty="0"/>
-              <a:t> skip (!</a:t>
-            </a:r>
-            <a:r>
-              <a:rPr lang="en-US" baseline="0" dirty="0" err="1"/>
-              <a:t>exc</a:t>
-            </a:r>
-            <a:r>
-              <a:rPr lang="en-US" baseline="0" dirty="0"/>
-              <a:t> /\ </a:t>
-            </a:r>
-            <a:r>
-              <a:rPr lang="en-US" baseline="0" dirty="0" err="1"/>
-              <a:t>wlp</a:t>
-            </a:r>
-            <a:r>
-              <a:rPr lang="en-US" baseline="0" dirty="0"/>
-              <a:t> skip x=0)</a:t>
-            </a:r>
-          </a:p>
-          <a:p>
-            <a:r>
-              <a:rPr lang="en-US" baseline="0" dirty="0"/>
-              <a:t>  =</a:t>
-            </a:r>
-          </a:p>
-          <a:p>
-            <a:r>
-              <a:rPr lang="en-US" baseline="0" dirty="0"/>
-              <a:t>  (</a:t>
-            </a:r>
-            <a:r>
-              <a:rPr lang="en-US" baseline="0" dirty="0" err="1"/>
-              <a:t>exc</a:t>
-            </a:r>
-            <a:r>
-              <a:rPr lang="en-US" baseline="0" dirty="0"/>
-              <a:t> /\ x=0)  \/  (!</a:t>
-            </a:r>
-            <a:r>
-              <a:rPr lang="en-US" baseline="0" dirty="0" err="1"/>
-              <a:t>exc</a:t>
-            </a:r>
-            <a:r>
-              <a:rPr lang="en-US" baseline="0" dirty="0"/>
-              <a:t> /\ x=0)</a:t>
-            </a:r>
-            <a:endParaRPr lang="en-US" dirty="0"/>
-          </a:p>
-        </p:txBody>
-      </p:sp>
-      <p:sp>
-        <p:nvSpPr>
-          <p:cNvPr id="4" name="Slide Number Placeholder 3"/>
-          <p:cNvSpPr>
-            <a:spLocks noGrp="1"/>
-          </p:cNvSpPr>
-          <p:nvPr>
-            <p:ph type="sldNum" sz="quarter" idx="10"/>
-          </p:nvPr>
-        </p:nvSpPr>
-        <p:spPr/>
-        <p:txBody>
-          <a:bodyPr/>
-          <a:lstStyle/>
-          <a:p>
-            <a:pPr>
-              <a:defRPr/>
-            </a:pPr>
-            <a:fld id="{CA39CDBC-8017-4E8F-B9B6-0F2C75591882}" type="slidenum">
-              <a:rPr lang="en-US" smtClean="0"/>
-              <a:pPr>
-                <a:defRPr/>
-              </a:pPr>
-              <a:t>66</a:t>
-            </a:fld>
-            <a:endParaRPr lang="en-US"/>
-          </a:p>
-        </p:txBody>
-      </p:sp>
-    </p:spTree>
-    <p:extLst>
-      <p:ext uri="{BB962C8B-B14F-4D97-AF65-F5344CB8AC3E}">
-        <p14:creationId xmlns:p14="http://schemas.microsoft.com/office/powerpoint/2010/main" val="669800597"/>
-      </p:ext>
-    </p:extLst>
-  </p:cSld>
-  <p:clrMapOvr>
-    <a:masterClrMapping/>
-  </p:clrMapOvr>
-</p:notes>
-</file>
-
-<file path=ppt/notesSlides/notesSlide49.xml><?xml version="1.0" encoding="utf-8"?>
-<p:notes xmlns:a="http://schemas.openxmlformats.org/drawingml/2006/main" xmlns:r="http://schemas.openxmlformats.org/officeDocument/2006/relationships" xmlns:p="http://schemas.openxmlformats.org/presentationml/2006/main">
-  <p:cSld>
-    <p:spTree>
-      <p:nvGrpSpPr>
-        <p:cNvPr id="1" name=""/>
-        <p:cNvGrpSpPr/>
-        <p:nvPr/>
-      </p:nvGrpSpPr>
-      <p:grpSpPr>
-        <a:xfrm>
-          <a:off x="0" y="0"/>
-          <a:ext cx="0" cy="0"/>
-          <a:chOff x="0" y="0"/>
-          <a:chExt cx="0" cy="0"/>
-        </a:xfrm>
-      </p:grpSpPr>
-      <p:sp>
-        <p:nvSpPr>
-          <p:cNvPr id="2" name="Slide Image Placeholder 1"/>
-          <p:cNvSpPr>
-            <a:spLocks noGrp="1" noRot="1" noChangeAspect="1"/>
-          </p:cNvSpPr>
-          <p:nvPr>
-            <p:ph type="sldImg"/>
-          </p:nvPr>
-        </p:nvSpPr>
-        <p:spPr/>
-      </p:sp>
-      <p:sp>
-        <p:nvSpPr>
-          <p:cNvPr id="3" name="Notes Placeholder 2"/>
-          <p:cNvSpPr>
-            <a:spLocks noGrp="1"/>
-          </p:cNvSpPr>
-          <p:nvPr>
-            <p:ph type="body" idx="1"/>
-          </p:nvPr>
-        </p:nvSpPr>
-        <p:spPr/>
-        <p:txBody>
-          <a:bodyPr>
-            <a:normAutofit fontScale="85000" lnSpcReduction="20000"/>
-          </a:bodyPr>
-          <a:lstStyle/>
-          <a:p>
-            <a:r>
-              <a:rPr lang="en-US" dirty="0"/>
-              <a:t>example:</a:t>
-            </a:r>
-          </a:p>
-          <a:p>
-            <a:endParaRPr lang="en-US" dirty="0"/>
-          </a:p>
-          <a:p>
-            <a:r>
-              <a:rPr lang="en-US" dirty="0" err="1"/>
-              <a:t>wlp</a:t>
-            </a:r>
-            <a:r>
-              <a:rPr lang="en-US" dirty="0"/>
-              <a:t>  (if (x=0)</a:t>
-            </a:r>
-            <a:r>
-              <a:rPr lang="en-US" baseline="0" dirty="0"/>
-              <a:t> raise else skip) ! x=1  { x&gt;0 }</a:t>
-            </a:r>
-          </a:p>
-          <a:p>
-            <a:endParaRPr lang="en-US" baseline="0" dirty="0"/>
-          </a:p>
-          <a:p>
-            <a:r>
-              <a:rPr lang="en-US" baseline="0" dirty="0"/>
-              <a:t>= </a:t>
-            </a:r>
-            <a:r>
-              <a:rPr lang="en-US" baseline="0" dirty="0" err="1"/>
-              <a:t>wlp</a:t>
-            </a:r>
-            <a:r>
-              <a:rPr lang="en-US" baseline="0" dirty="0"/>
-              <a:t>  (</a:t>
-            </a:r>
-            <a:r>
-              <a:rPr lang="en-US" dirty="0"/>
-              <a:t>if (x=0)</a:t>
-            </a:r>
-            <a:r>
-              <a:rPr lang="en-US" baseline="0" dirty="0"/>
-              <a:t> raise else skip)) (~</a:t>
-            </a:r>
-            <a:r>
-              <a:rPr lang="en-US" baseline="0" dirty="0" err="1"/>
-              <a:t>exc</a:t>
-            </a:r>
-            <a:r>
-              <a:rPr lang="en-US" baseline="0" dirty="0"/>
-              <a:t> /\ x&gt;0)  </a:t>
-            </a:r>
-          </a:p>
-          <a:p>
-            <a:r>
-              <a:rPr lang="en-US" baseline="0" dirty="0"/>
-              <a:t>    \/</a:t>
-            </a:r>
-          </a:p>
-          <a:p>
-            <a:r>
-              <a:rPr lang="en-US" baseline="0" dirty="0"/>
-              <a:t>    </a:t>
-            </a:r>
-            <a:r>
-              <a:rPr lang="en-US" baseline="0" dirty="0" err="1"/>
-              <a:t>wlp</a:t>
-            </a:r>
-            <a:r>
-              <a:rPr lang="en-US" baseline="0" dirty="0"/>
-              <a:t> (</a:t>
-            </a:r>
-            <a:r>
-              <a:rPr lang="en-US" dirty="0"/>
-              <a:t>if (x=0)</a:t>
-            </a:r>
-            <a:r>
-              <a:rPr lang="en-US" baseline="0" dirty="0"/>
-              <a:t> raise else skip))  (</a:t>
-            </a:r>
-            <a:r>
-              <a:rPr lang="en-US" baseline="0" dirty="0" err="1"/>
-              <a:t>exc</a:t>
-            </a:r>
-            <a:r>
-              <a:rPr lang="en-US" baseline="0" dirty="0"/>
-              <a:t> /\ 1&gt;0)</a:t>
-            </a:r>
-            <a:endParaRPr lang="en-US" baseline="0" dirty="0">
-              <a:sym typeface="Wingdings" pitchFamily="2" charset="2"/>
-            </a:endParaRPr>
-          </a:p>
-          <a:p>
-            <a:r>
-              <a:rPr lang="en-US" baseline="0" dirty="0"/>
-              <a:t>=</a:t>
-            </a:r>
-          </a:p>
-          <a:p>
-            <a:r>
-              <a:rPr lang="en-US" baseline="0" dirty="0"/>
-              <a:t>   (x=0 ==&gt; </a:t>
-            </a:r>
-            <a:r>
-              <a:rPr lang="en-US" baseline="0" dirty="0" err="1"/>
-              <a:t>wlp</a:t>
-            </a:r>
-            <a:r>
-              <a:rPr lang="en-US" baseline="0" dirty="0"/>
-              <a:t> raise (~</a:t>
-            </a:r>
-            <a:r>
-              <a:rPr lang="en-US" baseline="0" dirty="0" err="1"/>
-              <a:t>exc</a:t>
-            </a:r>
-            <a:r>
-              <a:rPr lang="en-US" baseline="0" dirty="0"/>
-              <a:t> /\ x&gt;0) ) /\ (x&lt;&gt;0 </a:t>
-            </a:r>
-            <a:r>
-              <a:rPr lang="en-US" baseline="0" dirty="0">
-                <a:sym typeface="Wingdings" pitchFamily="2" charset="2"/>
-              </a:rPr>
-              <a:t>==&gt; </a:t>
-            </a:r>
-            <a:r>
-              <a:rPr lang="en-US" baseline="0" dirty="0"/>
-              <a:t>(~</a:t>
-            </a:r>
-            <a:r>
-              <a:rPr lang="en-US" baseline="0" dirty="0" err="1"/>
-              <a:t>exc</a:t>
-            </a:r>
-            <a:r>
-              <a:rPr lang="en-US" baseline="0" dirty="0"/>
-              <a:t> /\ x&gt;0) )</a:t>
-            </a:r>
-          </a:p>
-          <a:p>
-            <a:r>
-              <a:rPr lang="en-US" baseline="0" dirty="0"/>
-              <a:t>   \/</a:t>
-            </a:r>
-          </a:p>
-          <a:p>
-            <a:r>
-              <a:rPr lang="en-US" baseline="0" dirty="0"/>
-              <a:t>  (x=0 ==&gt; </a:t>
-            </a:r>
-            <a:r>
-              <a:rPr lang="en-US" baseline="0" dirty="0" err="1"/>
-              <a:t>wlp</a:t>
-            </a:r>
-            <a:r>
-              <a:rPr lang="en-US" baseline="0" dirty="0"/>
-              <a:t> raise </a:t>
-            </a:r>
-            <a:r>
-              <a:rPr lang="en-US" baseline="0" dirty="0" err="1"/>
-              <a:t>exc</a:t>
-            </a:r>
-            <a:r>
-              <a:rPr lang="en-US" baseline="0" dirty="0"/>
-              <a:t>) /\ (x&lt;&gt;0 </a:t>
-            </a:r>
-            <a:r>
-              <a:rPr lang="en-US" baseline="0" dirty="0">
-                <a:sym typeface="Wingdings" pitchFamily="2" charset="2"/>
-              </a:rPr>
-              <a:t>==&gt; </a:t>
-            </a:r>
-            <a:r>
-              <a:rPr lang="en-US" baseline="0" dirty="0" err="1">
-                <a:sym typeface="Wingdings" pitchFamily="2" charset="2"/>
-              </a:rPr>
-              <a:t>e</a:t>
-            </a:r>
-            <a:r>
-              <a:rPr lang="en-US" baseline="0" dirty="0" err="1"/>
-              <a:t>xc</a:t>
-            </a:r>
-            <a:r>
-              <a:rPr lang="en-US" baseline="0" dirty="0"/>
-              <a:t>)</a:t>
-            </a:r>
-          </a:p>
-          <a:p>
-            <a:r>
-              <a:rPr lang="en-US" baseline="0" dirty="0"/>
-              <a:t>=</a:t>
-            </a:r>
-          </a:p>
-          <a:p>
-            <a:r>
-              <a:rPr lang="en-US" baseline="0" dirty="0"/>
-              <a:t>  (x=0 ==&gt; ~true /\ x&gt;0) ) /\ (x&lt;&gt;0 </a:t>
-            </a:r>
-            <a:r>
-              <a:rPr lang="en-US" baseline="0" dirty="0">
-                <a:sym typeface="Wingdings" pitchFamily="2" charset="2"/>
-              </a:rPr>
-              <a:t>==&gt; </a:t>
-            </a:r>
-            <a:r>
-              <a:rPr lang="en-US" baseline="0" dirty="0"/>
-              <a:t>(~</a:t>
-            </a:r>
-            <a:r>
-              <a:rPr lang="en-US" baseline="0" dirty="0" err="1"/>
-              <a:t>exc</a:t>
-            </a:r>
-            <a:r>
-              <a:rPr lang="en-US" baseline="0" dirty="0"/>
-              <a:t> /\ x&gt;0) )</a:t>
-            </a:r>
-          </a:p>
-          <a:p>
-            <a:r>
-              <a:rPr lang="en-US" baseline="0" dirty="0"/>
-              <a:t>  \/</a:t>
-            </a:r>
-          </a:p>
-          <a:p>
-            <a:r>
-              <a:rPr lang="en-US" baseline="0" dirty="0"/>
-              <a:t> (x=0 ==&gt; true) /\ (x&lt;&gt;0 </a:t>
-            </a:r>
-            <a:r>
-              <a:rPr lang="en-US" baseline="0" dirty="0">
-                <a:sym typeface="Wingdings" pitchFamily="2" charset="2"/>
-              </a:rPr>
-              <a:t>==&gt; </a:t>
-            </a:r>
-            <a:r>
-              <a:rPr lang="en-US" baseline="0" dirty="0" err="1">
-                <a:sym typeface="Wingdings" pitchFamily="2" charset="2"/>
-              </a:rPr>
-              <a:t>e</a:t>
-            </a:r>
-            <a:r>
-              <a:rPr lang="en-US" baseline="0" dirty="0" err="1"/>
-              <a:t>xc</a:t>
-            </a:r>
-            <a:r>
-              <a:rPr lang="en-US" baseline="0" dirty="0"/>
-              <a:t>)</a:t>
-            </a:r>
-          </a:p>
-          <a:p>
-            <a:r>
-              <a:rPr lang="en-US" baseline="0" dirty="0"/>
-              <a:t>=</a:t>
-            </a:r>
-          </a:p>
-          <a:p>
-            <a:r>
-              <a:rPr lang="en-US" baseline="0" dirty="0"/>
-              <a:t> (x=0 ==&gt; false) /\ (x&lt;&gt;0 </a:t>
-            </a:r>
-            <a:r>
-              <a:rPr lang="en-US" baseline="0" dirty="0">
-                <a:sym typeface="Wingdings" pitchFamily="2" charset="2"/>
-              </a:rPr>
-              <a:t>==&gt; </a:t>
-            </a:r>
-            <a:r>
-              <a:rPr lang="en-US" baseline="0" dirty="0"/>
-              <a:t>(~</a:t>
-            </a:r>
-            <a:r>
-              <a:rPr lang="en-US" baseline="0" dirty="0" err="1"/>
-              <a:t>exc</a:t>
-            </a:r>
-            <a:r>
-              <a:rPr lang="en-US" baseline="0" dirty="0"/>
-              <a:t> /\ x&gt;0) )</a:t>
-            </a:r>
-          </a:p>
-          <a:p>
-            <a:r>
-              <a:rPr lang="en-US" baseline="0" dirty="0"/>
-              <a:t> \/</a:t>
-            </a:r>
-          </a:p>
-          <a:p>
-            <a:r>
-              <a:rPr lang="en-US" baseline="0" dirty="0"/>
-              <a:t> true /\  (x&lt;&gt;0 </a:t>
-            </a:r>
-            <a:r>
-              <a:rPr lang="en-US" baseline="0" dirty="0">
-                <a:sym typeface="Wingdings" pitchFamily="2" charset="2"/>
-              </a:rPr>
-              <a:t>==&gt; </a:t>
-            </a:r>
-            <a:r>
-              <a:rPr lang="en-US" baseline="0" dirty="0" err="1">
-                <a:sym typeface="Wingdings" pitchFamily="2" charset="2"/>
-              </a:rPr>
-              <a:t>e</a:t>
-            </a:r>
-            <a:r>
-              <a:rPr lang="en-US" baseline="0" dirty="0" err="1"/>
-              <a:t>xc</a:t>
-            </a:r>
-            <a:r>
-              <a:rPr lang="en-US" baseline="0" dirty="0"/>
-              <a:t>)</a:t>
-            </a:r>
-          </a:p>
-          <a:p>
-            <a:r>
-              <a:rPr lang="en-US" baseline="0" dirty="0"/>
-              <a:t>=</a:t>
-            </a:r>
-          </a:p>
-          <a:p>
-            <a:r>
-              <a:rPr lang="en-US" baseline="0" dirty="0"/>
-              <a:t>  (x&lt;&gt;0 </a:t>
-            </a:r>
-            <a:r>
-              <a:rPr lang="en-US" baseline="0" dirty="0">
-                <a:sym typeface="Wingdings" pitchFamily="2" charset="2"/>
-              </a:rPr>
-              <a:t>/\ </a:t>
-            </a:r>
-            <a:r>
-              <a:rPr lang="en-US" baseline="0" dirty="0"/>
-              <a:t>~</a:t>
-            </a:r>
-            <a:r>
-              <a:rPr lang="en-US" baseline="0" dirty="0" err="1"/>
-              <a:t>exc</a:t>
-            </a:r>
-            <a:r>
-              <a:rPr lang="en-US" baseline="0" dirty="0"/>
-              <a:t> /\ x&gt;0)</a:t>
-            </a:r>
-          </a:p>
-          <a:p>
-            <a:r>
-              <a:rPr lang="en-US" baseline="0" dirty="0"/>
-              <a:t>   \/</a:t>
-            </a:r>
-          </a:p>
-          <a:p>
-            <a:r>
-              <a:rPr lang="en-US" baseline="0" dirty="0"/>
-              <a:t>  x=0 \/ </a:t>
-            </a:r>
-            <a:r>
-              <a:rPr lang="en-US" baseline="0" dirty="0" err="1"/>
-              <a:t>exc</a:t>
-            </a:r>
-            <a:endParaRPr lang="en-US" baseline="0" dirty="0"/>
-          </a:p>
-        </p:txBody>
-      </p:sp>
-      <p:sp>
-        <p:nvSpPr>
-          <p:cNvPr id="4" name="Slide Number Placeholder 3"/>
-          <p:cNvSpPr>
-            <a:spLocks noGrp="1"/>
-          </p:cNvSpPr>
-          <p:nvPr>
-            <p:ph type="sldNum" sz="quarter" idx="10"/>
-          </p:nvPr>
-        </p:nvSpPr>
-        <p:spPr/>
-        <p:txBody>
-          <a:bodyPr/>
-          <a:lstStyle/>
-          <a:p>
-            <a:pPr>
-              <a:defRPr/>
-            </a:pPr>
-            <a:fld id="{CA39CDBC-8017-4E8F-B9B6-0F2C75591882}" type="slidenum">
-              <a:rPr lang="en-US" smtClean="0"/>
-              <a:pPr>
-                <a:defRPr/>
-              </a:pPr>
-              <a:t>69</a:t>
-            </a:fld>
-            <a:endParaRPr lang="en-US"/>
-          </a:p>
-        </p:txBody>
-      </p:sp>
-    </p:spTree>
-    <p:extLst>
-      <p:ext uri="{BB962C8B-B14F-4D97-AF65-F5344CB8AC3E}">
-        <p14:creationId xmlns:p14="http://schemas.microsoft.com/office/powerpoint/2010/main" val="1938341516"/>
       </p:ext>
     </p:extLst>
   </p:cSld>
@@ -35134,7 +34466,7 @@
             </a:r>
             <a:r>
               <a:rPr lang="en-US" dirty="0"/>
-              <a:t>times; higher iterations are ignored/removed.</a:t>
+              <a:t>times; higher iterations are ignored.</a:t>
             </a:r>
             <a:endParaRPr lang="nl-NL" dirty="0"/>
           </a:p>
@@ -39975,7 +39307,13 @@
       </p:grpSpPr>
       <p:sp>
         <p:nvSpPr>
-          <p:cNvPr id="2" name="Title 1"/>
+          <p:cNvPr id="2" name="Title 1">
+            <a:extLst>
+              <a:ext uri="{FF2B5EF4-FFF2-40B4-BE49-F238E27FC236}">
+                <a16:creationId xmlns:a16="http://schemas.microsoft.com/office/drawing/2014/main" id="{53F000A2-D478-5016-302D-87280B6F610E}"/>
+              </a:ext>
+            </a:extLst>
+          </p:cNvPr>
           <p:cNvSpPr>
             <a:spLocks noGrp="1"/>
           </p:cNvSpPr>
@@ -39989,15 +39327,21 @@
           <a:lstStyle/>
           <a:p>
             <a:r>
-              <a:rPr lang="en-US" dirty="0"/>
-              <a:t>Exception</a:t>
-            </a:r>
-          </a:p>
-        </p:txBody>
-      </p:sp>
-      <p:sp>
-        <p:nvSpPr>
-          <p:cNvPr id="3" name="Content Placeholder 2"/>
+              <a:rPr lang="en-NL" dirty="0"/>
+              <a:t>excEption</a:t>
+            </a:r>
+          </a:p>
+        </p:txBody>
+      </p:sp>
+      <p:sp>
+        <p:nvSpPr>
+          <p:cNvPr id="3" name="Content Placeholder 2">
+            <a:extLst>
+              <a:ext uri="{FF2B5EF4-FFF2-40B4-BE49-F238E27FC236}">
+                <a16:creationId xmlns:a16="http://schemas.microsoft.com/office/drawing/2014/main" id="{9C735CE4-7EA5-0CA3-4F8F-004B1CB565C8}"/>
+              </a:ext>
+            </a:extLst>
+          </p:cNvPr>
           <p:cNvSpPr>
             <a:spLocks noGrp="1"/>
           </p:cNvSpPr>
@@ -40007,107 +39351,125 @@
         </p:nvSpPr>
         <p:spPr/>
         <p:txBody>
-          <a:bodyPr/>
+          <a:bodyPr>
+            <a:normAutofit fontScale="92500" lnSpcReduction="10000"/>
+          </a:bodyPr>
           <a:lstStyle/>
           <a:p>
             <a:r>
-              <a:rPr lang="en-US" sz="2400" dirty="0"/>
-              <a:t>Exception introduces non-standard flow of execution, which are often error prone.</a:t>
-            </a:r>
-          </a:p>
-          <a:p>
-            <a:r>
-              <a:rPr lang="en-US" sz="2400" dirty="0"/>
-              <a:t>The problem is, exception can be thrown from many points in the program, basically exploding the goals to solve for verification.</a:t>
-            </a:r>
-          </a:p>
-          <a:p>
-            <a:r>
-              <a:rPr lang="en-US" sz="2400" dirty="0"/>
-              <a:t>But first ... how to deal with exception in Hoare logic / </a:t>
-            </a:r>
-            <a:r>
-              <a:rPr lang="en-US" sz="2400" b="1" dirty="0" err="1"/>
-              <a:t>wlp</a:t>
-            </a:r>
-            <a:r>
-              <a:rPr lang="en-US" sz="2400" dirty="0"/>
-              <a:t> ?</a:t>
-            </a:r>
-          </a:p>
-          <a:p>
-            <a:pPr lvl="1"/>
-            <a:r>
-              <a:rPr lang="en-US" dirty="0"/>
-              <a:t>Approach-1 : introduce a variable </a:t>
-            </a:r>
-            <a:r>
-              <a:rPr lang="en-US" i="1" dirty="0" err="1"/>
-              <a:t>exc</a:t>
-            </a:r>
-            <a:r>
-              <a:rPr lang="en-US" dirty="0"/>
-              <a:t> to represent that the program has entered an exceptional state, and explicitly encode the flow in the </a:t>
-            </a:r>
-            <a:r>
-              <a:rPr lang="en-US" b="1" dirty="0" err="1"/>
-              <a:t>wlp</a:t>
-            </a:r>
-            <a:r>
-              <a:rPr lang="en-US" dirty="0">
-                <a:sym typeface="Wingdings"/>
-              </a:rPr>
+              <a:rPr lang="en-NL" dirty="0"/>
+              <a:t>In an actual language, many expressions can throw an exception, e.g x/y if y happens to be zero.</a:t>
+            </a:r>
+          </a:p>
+          <a:p>
+            <a:endParaRPr lang="en-NL" dirty="0"/>
+          </a:p>
+          <a:p>
+            <a:r>
+              <a:rPr lang="en-NL" dirty="0"/>
+              <a:t>Consider this try-catch extension to GCL:   </a:t>
+            </a:r>
+            <a:r>
+              <a:rPr lang="en-NL" i="1" dirty="0">
+                <a:highlight>
+                  <a:srgbClr val="FFFF00"/>
+                </a:highlight>
+              </a:rPr>
+              <a:t>S</a:t>
+            </a:r>
+            <a:r>
+              <a:rPr lang="en-NL" dirty="0">
+                <a:highlight>
+                  <a:srgbClr val="FFFF00"/>
+                </a:highlight>
+              </a:rPr>
+              <a:t> ! </a:t>
+            </a:r>
+            <a:r>
+              <a:rPr lang="en-NL" i="1" dirty="0">
+                <a:highlight>
+                  <a:srgbClr val="FFFF00"/>
+                </a:highlight>
+              </a:rPr>
+              <a:t>H</a:t>
+            </a:r>
+            <a:r>
+              <a:rPr lang="en-NL" dirty="0"/>
+              <a:t>, execute the statement </a:t>
+            </a:r>
+            <a:r>
+              <a:rPr lang="en-NL" i="1" dirty="0"/>
+              <a:t>S</a:t>
+            </a:r>
+            <a:r>
+              <a:rPr lang="en-NL" dirty="0"/>
+              <a:t>. If this throws an exception, jump to the handler </a:t>
+            </a:r>
+            <a:r>
+              <a:rPr lang="en-NL" i="1" dirty="0"/>
+              <a:t>H</a:t>
+            </a:r>
+            <a:r>
+              <a:rPr lang="en-NL" dirty="0"/>
               <a:t>.</a:t>
             </a:r>
-            <a:endParaRPr lang="en-US" dirty="0"/>
-          </a:p>
-          <a:p>
-            <a:pPr lvl="1"/>
-            <a:r>
-              <a:rPr lang="en-US" sz="2000" dirty="0"/>
-              <a:t>Approach-2: extend post-condition to be a pair (</a:t>
-            </a:r>
-            <a:r>
-              <a:rPr lang="en-US" sz="2000" i="1" dirty="0" err="1"/>
-              <a:t>Q</a:t>
-            </a:r>
-            <a:r>
-              <a:rPr lang="en-US" sz="2000" baseline="-25000" dirty="0" err="1"/>
-              <a:t>n</a:t>
-            </a:r>
-            <a:r>
-              <a:rPr lang="en-US" sz="2000" dirty="0" err="1"/>
-              <a:t>,</a:t>
-            </a:r>
-            <a:r>
-              <a:rPr lang="en-US" sz="2000" i="1" dirty="0" err="1"/>
-              <a:t>Q</a:t>
-            </a:r>
-            <a:r>
-              <a:rPr lang="en-US" sz="2000" baseline="-25000" dirty="0" err="1"/>
-              <a:t>e</a:t>
-            </a:r>
-            <a:r>
-              <a:rPr lang="en-US" sz="2000" dirty="0"/>
-              <a:t>) representing the desired situation when a program terminates normally, and when it terminates exceptionally.</a:t>
-            </a:r>
-          </a:p>
-          <a:p>
-            <a:pPr lvl="1"/>
-            <a:r>
-              <a:rPr lang="en-US" dirty="0"/>
-              <a:t>Approach-3: represent a program as a control flow graph</a:t>
-            </a:r>
-            <a:endParaRPr lang="en-US" sz="2000" dirty="0"/>
-          </a:p>
-          <a:p>
-            <a:endParaRPr lang="en-US" sz="2400" dirty="0"/>
-          </a:p>
-        </p:txBody>
-      </p:sp>
-      <p:sp>
-        <p:nvSpPr>
-          <p:cNvPr id="4" name="Slide Number Placeholder 3"/>
+          </a:p>
+          <a:p>
+            <a:endParaRPr lang="en-NL" dirty="0"/>
+          </a:p>
+          <a:p>
+            <a:r>
+              <a:rPr lang="en-NL" dirty="0"/>
+              <a:t>We also add the statement </a:t>
+            </a:r>
+            <a:r>
+              <a:rPr lang="en-NL" b="1" dirty="0">
+                <a:highlight>
+                  <a:srgbClr val="FFFF00"/>
+                </a:highlight>
+              </a:rPr>
+              <a:t>raise</a:t>
+            </a:r>
+            <a:r>
+              <a:rPr lang="en-NL" dirty="0"/>
+              <a:t>, to throw an exception. To keep it simple, there is only one type of exception.</a:t>
+            </a:r>
+          </a:p>
+          <a:p>
+            <a:endParaRPr lang="en-NL" dirty="0"/>
+          </a:p>
+          <a:p>
+            <a:r>
+              <a:rPr lang="en-NL" dirty="0"/>
+              <a:t>Calculating wlp is now more complicated, because </a:t>
+            </a:r>
+            <a:r>
+              <a:rPr lang="en-NL" b="1" dirty="0"/>
+              <a:t>raise</a:t>
+            </a:r>
+            <a:r>
+              <a:rPr lang="en-NL" dirty="0"/>
+              <a:t> can cause a jump in the execution.</a:t>
+            </a:r>
+            <a:br>
+              <a:rPr lang="en-NL" dirty="0"/>
+            </a:br>
+            <a:br>
+              <a:rPr lang="en-NL" dirty="0"/>
+            </a:br>
+            <a:endParaRPr lang="en-NL" dirty="0"/>
+          </a:p>
+        </p:txBody>
+      </p:sp>
+      <p:sp>
+        <p:nvSpPr>
+          <p:cNvPr id="4" name="Slide Number Placeholder 3">
+            <a:extLst>
+              <a:ext uri="{FF2B5EF4-FFF2-40B4-BE49-F238E27FC236}">
+                <a16:creationId xmlns:a16="http://schemas.microsoft.com/office/drawing/2014/main" id="{208DDBD4-E8F7-AB5E-77C2-382C112FAE8A}"/>
+              </a:ext>
+            </a:extLst>
+          </p:cNvPr>
           <p:cNvSpPr>
             <a:spLocks noGrp="1"/>
           </p:cNvSpPr>
@@ -40123,7 +39485,7 @@
             <a:pPr>
               <a:defRPr/>
             </a:pPr>
-            <a:fld id="{848220AE-4ABF-4647-9677-DBC7878747C7}" type="slidenum">
+            <a:fld id="{58A332FB-769C-4CBB-BDDE-0DC26211CC04}" type="slidenum">
               <a:rPr lang="en-US" smtClean="0"/>
               <a:pPr>
                 <a:defRPr/>
@@ -40137,7 +39499,7 @@
     </p:spTree>
     <p:extLst>
       <p:ext uri="{BB962C8B-B14F-4D97-AF65-F5344CB8AC3E}">
-        <p14:creationId xmlns:p14="http://schemas.microsoft.com/office/powerpoint/2010/main" val="295763964"/>
+        <p14:creationId xmlns:p14="http://schemas.microsoft.com/office/powerpoint/2010/main" val="2256650760"/>
       </p:ext>
     </p:extLst>
   </p:cSld>
@@ -40181,7 +39543,7 @@
           <a:p>
             <a:r>
               <a:rPr lang="en-US" dirty="0"/>
-              <a:t>Approach 1</a:t>
+              <a:t>Assignments and guards</a:t>
             </a:r>
           </a:p>
         </p:txBody>
@@ -40196,112 +39558,124 @@
             <p:ph idx="1"/>
           </p:nvPr>
         </p:nvSpPr>
-        <p:spPr/>
-        <p:txBody>
-          <a:bodyPr/>
+        <p:spPr>
+          <a:xfrm>
+            <a:off x="762000" y="1295400"/>
+            <a:ext cx="8382000" cy="4724400"/>
+          </a:xfrm>
+        </p:spPr>
+        <p:txBody>
+          <a:bodyPr>
+            <a:normAutofit/>
+          </a:bodyPr>
           <a:lstStyle/>
           <a:p>
             <a:r>
               <a:rPr lang="en-US" dirty="0"/>
-              <a:t>Introduce a global variable </a:t>
-            </a:r>
-            <a:r>
-              <a:rPr lang="en-US" i="1" dirty="0" err="1"/>
-              <a:t>exc</a:t>
-            </a:r>
-            <a:r>
-              <a:rPr lang="en-US" i="1" dirty="0"/>
-              <a:t> : </a:t>
+              <a:t>When reasoning about programs, we can either insist that they do not throw an exception. We can do this by adding “asserts”. E.g. :</a:t>
+            </a:r>
+            <a:br>
+              <a:rPr lang="en-US" dirty="0"/>
+            </a:br>
+            <a:br>
+              <a:rPr lang="en-US" dirty="0"/>
+            </a:br>
+            <a:r>
+              <a:rPr lang="en-US" dirty="0"/>
+              <a:t>	x := a[k]/y</a:t>
+            </a:r>
+            <a:br>
+              <a:rPr lang="en-US" dirty="0"/>
+            </a:br>
+            <a:br>
+              <a:rPr lang="en-US" dirty="0"/>
+            </a:br>
+            <a:r>
+              <a:rPr lang="en-US" dirty="0"/>
+              <a:t>is transformed to:</a:t>
+            </a:r>
+            <a:br>
+              <a:rPr lang="en-US" dirty="0"/>
+            </a:br>
+            <a:br>
+              <a:rPr lang="en-US" dirty="0"/>
+            </a:br>
+            <a:r>
+              <a:rPr lang="en-US" dirty="0"/>
+              <a:t>    </a:t>
+            </a:r>
+            <a:r>
+              <a:rPr lang="en-US" b="1" dirty="0"/>
+              <a:t>assert</a:t>
+            </a:r>
+            <a:r>
+              <a:rPr lang="en-US" dirty="0"/>
+              <a:t> 0≤k&lt;</a:t>
+            </a:r>
+            <a:r>
+              <a:rPr lang="en-US" dirty="0">
+                <a:sym typeface="Symbol"/>
+              </a:rPr>
+              <a:t>#a ; </a:t>
+            </a:r>
+            <a:br>
+              <a:rPr lang="en-US" dirty="0">
+                <a:sym typeface="Symbol"/>
+              </a:rPr>
+            </a:br>
+            <a:r>
+              <a:rPr lang="en-US" dirty="0">
+                <a:sym typeface="Symbol"/>
+              </a:rPr>
+              <a:t>    </a:t>
+            </a:r>
+            <a:r>
+              <a:rPr lang="en-US" b="1" dirty="0">
+                <a:sym typeface="Symbol"/>
+              </a:rPr>
+              <a:t>assert</a:t>
+            </a:r>
+            <a:r>
+              <a:rPr lang="en-US" dirty="0">
+                <a:sym typeface="Symbol"/>
+              </a:rPr>
+              <a:t> y≠0 ; </a:t>
+            </a:r>
+            <a:br>
+              <a:rPr lang="en-US" dirty="0">
+                <a:sym typeface="Symbol"/>
+              </a:rPr>
+            </a:br>
+            <a:r>
+              <a:rPr lang="en-US" dirty="0"/>
+              <a:t>    x := a[k]/y  ;</a:t>
+            </a:r>
+          </a:p>
+          <a:p>
+            <a:pPr marL="0" indent="0">
+              <a:buNone/>
+            </a:pPr>
+            <a:endParaRPr lang="en-US" dirty="0"/>
+          </a:p>
+          <a:p>
+            <a:r>
+              <a:rPr lang="en-US" dirty="0"/>
+              <a:t>Similar situation with guards in </a:t>
             </a:r>
             <a:r>
               <a:rPr lang="en-US" dirty="0" err="1"/>
-              <a:t>bool</a:t>
-            </a:r>
-            <a:r>
-              <a:rPr lang="en-US" dirty="0"/>
-              <a:t>, initially false</a:t>
-            </a:r>
-          </a:p>
-          <a:p>
-            <a:r>
-              <a:rPr lang="en-US" b="1" dirty="0"/>
-              <a:t>raise</a:t>
-            </a:r>
-            <a:r>
-              <a:rPr lang="en-US" dirty="0"/>
-              <a:t> sets this variable to true</a:t>
-            </a:r>
-          </a:p>
-          <a:p>
-            <a:r>
-              <a:rPr lang="en-US" dirty="0"/>
-              <a:t>entering a handler resets it to false</a:t>
-            </a:r>
-          </a:p>
-          <a:p>
-            <a:r>
-              <a:rPr lang="en-US" dirty="0"/>
-              <a:t>A state where </a:t>
-            </a:r>
-            <a:r>
-              <a:rPr lang="en-US" i="1" dirty="0" err="1"/>
-              <a:t>exc</a:t>
-            </a:r>
-            <a:r>
-              <a:rPr lang="en-US" dirty="0"/>
-              <a:t> is true, is an ‘exceptional’ state, else it is a normal state.</a:t>
-            </a:r>
-          </a:p>
-          <a:p>
-            <a:r>
-              <a:rPr lang="en-US" dirty="0"/>
-              <a:t>Multiple exception types can be encoded, but let’s ignore this here...</a:t>
-            </a:r>
-          </a:p>
-          <a:p>
-            <a:r>
-              <a:rPr lang="en-US" dirty="0"/>
-              <a:t>The obvious:</a:t>
-            </a:r>
-            <a:br>
-              <a:rPr lang="en-US" dirty="0"/>
-            </a:br>
-            <a:r>
-              <a:rPr lang="en-US" dirty="0"/>
-              <a:t>    </a:t>
-            </a:r>
-            <a:r>
-              <a:rPr lang="en-US" b="1" dirty="0" err="1"/>
-              <a:t>wlp</a:t>
-            </a:r>
-            <a:r>
-              <a:rPr lang="en-US" b="1" dirty="0"/>
-              <a:t> </a:t>
-            </a:r>
-            <a:r>
-              <a:rPr lang="en-US" dirty="0"/>
-              <a:t> </a:t>
-            </a:r>
-            <a:r>
-              <a:rPr lang="en-US" b="1" dirty="0"/>
-              <a:t>raise </a:t>
-            </a:r>
-            <a:r>
-              <a:rPr lang="en-US" i="1" dirty="0"/>
-              <a:t>Q  =  Q</a:t>
-            </a:r>
-            <a:r>
-              <a:rPr lang="en-US" dirty="0"/>
-              <a:t>[true/</a:t>
-            </a:r>
-            <a:r>
-              <a:rPr lang="en-US" i="1" dirty="0" err="1"/>
-              <a:t>exc</a:t>
-            </a:r>
-            <a:r>
-              <a:rPr lang="en-US" dirty="0"/>
-              <a:t>]</a:t>
-            </a:r>
+              <a:t>ite</a:t>
+            </a:r>
+            <a:r>
+              <a:rPr lang="en-US" dirty="0"/>
+              <a:t> and loop.</a:t>
+            </a:r>
+          </a:p>
+          <a:p>
+            <a:endParaRPr lang="en-US" dirty="0"/>
+          </a:p>
+          <a:p>
+            <a:endParaRPr lang="en-US" dirty="0"/>
           </a:p>
         </p:txBody>
       </p:sp>
@@ -40337,7 +39711,7 @@
     </p:spTree>
     <p:extLst>
       <p:ext uri="{BB962C8B-B14F-4D97-AF65-F5344CB8AC3E}">
-        <p14:creationId xmlns:p14="http://schemas.microsoft.com/office/powerpoint/2010/main" val="1627783790"/>
+        <p14:creationId xmlns:p14="http://schemas.microsoft.com/office/powerpoint/2010/main" val="229356205"/>
       </p:ext>
     </p:extLst>
   </p:cSld>
@@ -40374,19 +39748,14 @@
             <p:ph type="title"/>
           </p:nvPr>
         </p:nvSpPr>
-        <p:spPr>
-          <a:xfrm>
-            <a:off x="500034" y="274638"/>
-            <a:ext cx="8358246" cy="1096962"/>
-          </a:xfrm>
-        </p:spPr>
+        <p:spPr/>
         <p:txBody>
           <a:bodyPr/>
           <a:lstStyle/>
           <a:p>
             <a:r>
               <a:rPr lang="en-US" dirty="0"/>
-              <a:t>Approach 1</a:t>
+              <a:t>Assignments and guards</a:t>
             </a:r>
           </a:p>
         </p:txBody>
@@ -40403,91 +39772,38 @@
         </p:nvSpPr>
         <p:spPr>
           <a:xfrm>
-            <a:off x="500034" y="1714500"/>
-            <a:ext cx="8358246" cy="4723878"/>
+            <a:off x="500034" y="1447800"/>
+            <a:ext cx="8643966" cy="4572000"/>
           </a:xfrm>
         </p:spPr>
         <p:txBody>
-          <a:bodyPr>
-            <a:normAutofit/>
-          </a:bodyPr>
+          <a:bodyPr/>
           <a:lstStyle/>
           <a:p>
             <a:r>
               <a:rPr lang="en-US" dirty="0"/>
-              <a:t>S</a:t>
-            </a:r>
-            <a:r>
-              <a:rPr lang="en-US" baseline="-25000" dirty="0"/>
-              <a:t>1</a:t>
-            </a:r>
-            <a:r>
-              <a:rPr lang="en-US" dirty="0"/>
-              <a:t> ; S</a:t>
-            </a:r>
-            <a:r>
-              <a:rPr lang="en-US" baseline="-25000" dirty="0"/>
-              <a:t>2</a:t>
-            </a:r>
-            <a:r>
-              <a:rPr lang="en-US" dirty="0"/>
-              <a:t>  is treated as:</a:t>
-            </a:r>
-            <a:r>
-              <a:rPr lang="en-US" dirty="0">
-                <a:sym typeface="Symbol"/>
-              </a:rPr>
-              <a:t>   </a:t>
-            </a:r>
-            <a:r>
-              <a:rPr lang="en-US" dirty="0"/>
-              <a:t>S</a:t>
-            </a:r>
-            <a:r>
-              <a:rPr lang="en-US" baseline="-25000" dirty="0"/>
-              <a:t>1</a:t>
-            </a:r>
-            <a:r>
-              <a:rPr lang="en-US" dirty="0"/>
-              <a:t> ; </a:t>
-            </a:r>
-            <a:r>
-              <a:rPr lang="en-US" b="1" dirty="0"/>
-              <a:t>if</a:t>
-            </a:r>
-            <a:r>
-              <a:rPr lang="en-US" dirty="0"/>
-              <a:t> </a:t>
-            </a:r>
-            <a:r>
-              <a:rPr lang="en-US" dirty="0" err="1"/>
-              <a:t>exc</a:t>
-            </a:r>
-            <a:r>
-              <a:rPr lang="en-US" dirty="0"/>
-              <a:t> </a:t>
-            </a:r>
-            <a:r>
-              <a:rPr lang="en-US" b="1" dirty="0"/>
-              <a:t>then</a:t>
-            </a:r>
-            <a:r>
-              <a:rPr lang="en-US" dirty="0"/>
-              <a:t> skip </a:t>
-            </a:r>
-            <a:r>
-              <a:rPr lang="en-US" b="1" dirty="0"/>
-              <a:t>else</a:t>
-            </a:r>
-            <a:r>
-              <a:rPr lang="en-US" dirty="0"/>
-              <a:t> S</a:t>
-            </a:r>
-            <a:r>
-              <a:rPr lang="en-US" baseline="-25000" dirty="0"/>
-              <a:t>2</a:t>
-            </a:r>
-            <a:endParaRPr lang="en-US" b="1" dirty="0"/>
+              <a:t>Or we model exception throwing executions.  E.g. :</a:t>
+            </a:r>
+            <a:br>
+              <a:rPr lang="en-US" dirty="0"/>
+            </a:br>
+            <a:br>
+              <a:rPr lang="en-US" dirty="0"/>
+            </a:br>
+            <a:r>
+              <a:rPr lang="en-US" dirty="0"/>
+              <a:t>                x := a[k]/y</a:t>
+            </a:r>
+            <a:br>
+              <a:rPr lang="en-US" dirty="0"/>
+            </a:br>
+            <a:br>
+              <a:rPr lang="en-US" dirty="0"/>
+            </a:br>
+            <a:r>
+              <a:rPr lang="en-US" dirty="0"/>
+              <a:t>is then transformed to  :</a:t>
+            </a:r>
           </a:p>
           <a:p>
             <a:pPr marL="0" indent="0">
@@ -40497,100 +39813,126 @@
               <a:rPr lang="en-US" dirty="0"/>
             </a:br>
             <a:r>
+              <a:rPr lang="en-US" dirty="0"/>
+              <a:t>    </a:t>
+            </a:r>
+            <a:r>
               <a:rPr lang="en-US" b="1" dirty="0"/>
-              <a:t>Downside</a:t>
-            </a:r>
-            <a:r>
-              <a:rPr lang="en-US" dirty="0"/>
-              <a:t>: this blows up the resulting </a:t>
+              <a:t>if</a:t>
+            </a:r>
+            <a:r>
+              <a:rPr lang="en-US" dirty="0"/>
+              <a:t> k</a:t>
+            </a:r>
+            <a:r>
+              <a:rPr lang="en-US" dirty="0">
+                <a:sym typeface="Symbol"/>
+              </a:rPr>
+              <a:t>&lt;0 \/ k#a  </a:t>
+            </a:r>
+            <a:r>
+              <a:rPr lang="en-US" b="1" dirty="0">
+                <a:sym typeface="Symbol"/>
+              </a:rPr>
+              <a:t>then</a:t>
+            </a:r>
+            <a:r>
+              <a:rPr lang="en-US" dirty="0">
+                <a:sym typeface="Symbol"/>
+              </a:rPr>
+              <a:t> </a:t>
+            </a:r>
+            <a:r>
+              <a:rPr lang="en-US" b="1" dirty="0">
+                <a:sym typeface="Symbol"/>
+              </a:rPr>
+              <a:t>raise</a:t>
+            </a:r>
+            <a:r>
+              <a:rPr lang="en-US" dirty="0">
+                <a:sym typeface="Symbol"/>
+              </a:rPr>
+              <a:t> ; </a:t>
+            </a:r>
+            <a:br>
+              <a:rPr lang="en-US" dirty="0">
+                <a:sym typeface="Symbol"/>
+              </a:rPr>
+            </a:br>
+            <a:r>
+              <a:rPr lang="en-US" dirty="0">
+                <a:sym typeface="Symbol"/>
+              </a:rPr>
+              <a:t>    </a:t>
+            </a:r>
+            <a:r>
+              <a:rPr lang="en-US" b="1" dirty="0">
+                <a:sym typeface="Symbol"/>
+              </a:rPr>
+              <a:t>if</a:t>
+            </a:r>
+            <a:r>
+              <a:rPr lang="en-US" dirty="0">
+                <a:sym typeface="Symbol"/>
+              </a:rPr>
+              <a:t> y=0                </a:t>
+            </a:r>
+            <a:r>
+              <a:rPr lang="en-US" b="1" dirty="0">
+                <a:sym typeface="Symbol"/>
+              </a:rPr>
+              <a:t>then</a:t>
+            </a:r>
+            <a:r>
+              <a:rPr lang="en-US" dirty="0">
+                <a:sym typeface="Symbol"/>
+              </a:rPr>
+              <a:t> </a:t>
+            </a:r>
+            <a:r>
+              <a:rPr lang="en-US" b="1" dirty="0">
+                <a:sym typeface="Symbol"/>
+              </a:rPr>
+              <a:t>raise</a:t>
+            </a:r>
+            <a:r>
+              <a:rPr lang="en-US" dirty="0">
+                <a:sym typeface="Symbol"/>
+              </a:rPr>
+              <a:t> ; </a:t>
+            </a:r>
+            <a:br>
+              <a:rPr lang="en-US" dirty="0">
+                <a:sym typeface="Symbol"/>
+              </a:rPr>
+            </a:br>
+            <a:r>
+              <a:rPr lang="en-US" dirty="0"/>
+              <a:t>    x := a[k]/y  ;</a:t>
+            </a:r>
+          </a:p>
+          <a:p>
+            <a:endParaRPr lang="en-US" dirty="0"/>
+          </a:p>
+          <a:p>
+            <a:r>
+              <a:rPr lang="en-US" dirty="0"/>
+              <a:t>Similar situation with guards in </a:t>
             </a:r>
             <a:r>
               <a:rPr lang="en-US" dirty="0" err="1"/>
-              <a:t>wlp</a:t>
-            </a:r>
-            <a:r>
-              <a:rPr lang="en-US" dirty="0"/>
-              <a:t> since each  “;” will add one conditional clause</a:t>
-            </a:r>
-            <a:r>
-              <a:rPr lang="en-US" dirty="0">
-                <a:sym typeface="Wingdings" pitchFamily="2" charset="2"/>
-              </a:rPr>
-              <a:t>. </a:t>
-            </a:r>
-          </a:p>
-          <a:p>
-            <a:pPr marL="0" indent="0">
-              <a:buNone/>
-            </a:pPr>
-            <a:r>
-              <a:rPr lang="en-US" sz="2400" dirty="0"/>
-              <a:t>We can optimize this by statically checking if </a:t>
-            </a:r>
-            <a:r>
-              <a:rPr lang="en-US" sz="2400" dirty="0" err="1"/>
-              <a:t>exc</a:t>
-            </a:r>
-            <a:r>
-              <a:rPr lang="en-US" sz="2400" dirty="0"/>
-              <a:t> would be true after S</a:t>
-            </a:r>
-            <a:r>
-              <a:rPr lang="en-US" sz="2400" baseline="-25000" dirty="0"/>
-              <a:t>1</a:t>
-            </a:r>
-            <a:r>
-              <a:rPr lang="en-US" sz="2400" dirty="0"/>
-              <a:t>. If so, there is no need to expand S</a:t>
-            </a:r>
-            <a:r>
-              <a:rPr lang="en-US" sz="2400" baseline="-25000" dirty="0"/>
-              <a:t>2</a:t>
-            </a:r>
-            <a:r>
-              <a:rPr lang="en-US" sz="2400" dirty="0"/>
-              <a:t>.  Examples:</a:t>
-            </a:r>
-          </a:p>
-          <a:p>
-            <a:pPr lvl="2"/>
-            <a:r>
-              <a:rPr lang="en-US" sz="2400" dirty="0"/>
-              <a:t>S</a:t>
-            </a:r>
-            <a:r>
-              <a:rPr lang="en-US" sz="2400" baseline="-25000" dirty="0"/>
-              <a:t>1</a:t>
-            </a:r>
-            <a:r>
-              <a:rPr lang="en-US" sz="2400" dirty="0"/>
-              <a:t> does not  contain any raise stmt.</a:t>
-            </a:r>
-          </a:p>
-          <a:p>
-            <a:pPr lvl="2"/>
-            <a:r>
-              <a:rPr lang="en-US" sz="2400" dirty="0"/>
-              <a:t>S</a:t>
-            </a:r>
-            <a:r>
-              <a:rPr lang="en-US" sz="2400" baseline="-25000" dirty="0"/>
-              <a:t>1</a:t>
-            </a:r>
-            <a:r>
-              <a:rPr lang="en-US" sz="2400" dirty="0"/>
-              <a:t> is enclosed by an exception handler, that does not contain raise.</a:t>
-            </a:r>
-          </a:p>
-          <a:p>
-            <a:r>
-              <a:rPr lang="en-US" b="1" dirty="0"/>
-              <a:t>while </a:t>
-            </a:r>
-            <a:r>
-              <a:rPr lang="en-US" dirty="0"/>
-              <a:t>also need to be transformed due to the implicit sequencing  between iterations</a:t>
-            </a:r>
+              <a:t>ite</a:t>
+            </a:r>
+            <a:r>
+              <a:rPr lang="en-US" dirty="0"/>
+              <a:t> and loop.</a:t>
+            </a:r>
+          </a:p>
+          <a:p>
+            <a:endParaRPr lang="en-US" dirty="0"/>
+          </a:p>
+          <a:p>
+            <a:endParaRPr lang="en-US" dirty="0"/>
           </a:p>
         </p:txBody>
       </p:sp>
@@ -40626,7 +39968,7 @@
     </p:spTree>
     <p:extLst>
       <p:ext uri="{BB962C8B-B14F-4D97-AF65-F5344CB8AC3E}">
-        <p14:creationId xmlns:p14="http://schemas.microsoft.com/office/powerpoint/2010/main" val="1367979397"/>
+        <p14:creationId xmlns:p14="http://schemas.microsoft.com/office/powerpoint/2010/main" val="1970082773"/>
       </p:ext>
     </p:extLst>
   </p:cSld>
@@ -40670,7 +40012,7 @@
           <a:p>
             <a:r>
               <a:rPr lang="en-US" dirty="0"/>
-              <a:t>Assignments and guards</a:t>
+              <a:t>Exception</a:t>
             </a:r>
           </a:p>
         </p:txBody>
@@ -40685,132 +40027,91 @@
             <p:ph idx="1"/>
           </p:nvPr>
         </p:nvSpPr>
-        <p:spPr>
-          <a:xfrm>
-            <a:off x="762000" y="1295400"/>
-            <a:ext cx="8382000" cy="4724400"/>
-          </a:xfrm>
-        </p:spPr>
-        <p:txBody>
-          <a:bodyPr>
-            <a:normAutofit/>
-          </a:bodyPr>
+        <p:spPr/>
+        <p:txBody>
+          <a:bodyPr/>
           <a:lstStyle/>
           <a:p>
             <a:r>
-              <a:rPr lang="en-US" dirty="0"/>
-              <a:t>In GCL evaluating an expression does not crash; so you either have to </a:t>
-            </a:r>
-            <a:r>
-              <a:rPr lang="en-US" b="1" dirty="0"/>
-              <a:t>insist</a:t>
-            </a:r>
-            <a:r>
-              <a:rPr lang="en-US" dirty="0"/>
-              <a:t> that they don’t. E.g. :</a:t>
-            </a:r>
-            <a:br>
-              <a:rPr lang="en-US" dirty="0"/>
-            </a:br>
-            <a:br>
-              <a:rPr lang="en-US" dirty="0"/>
-            </a:br>
-            <a:r>
-              <a:rPr lang="en-US" dirty="0"/>
-              <a:t>	x := a[k]/y</a:t>
-            </a:r>
-            <a:br>
-              <a:rPr lang="en-US" dirty="0"/>
-            </a:br>
-            <a:br>
-              <a:rPr lang="en-US" dirty="0"/>
-            </a:br>
-            <a:r>
-              <a:rPr lang="en-US" dirty="0"/>
-              <a:t>is transformed to:</a:t>
-            </a:r>
-            <a:br>
-              <a:rPr lang="en-US" dirty="0"/>
-            </a:br>
-            <a:br>
-              <a:rPr lang="en-US" dirty="0"/>
-            </a:br>
-            <a:r>
-              <a:rPr lang="en-US" dirty="0"/>
-              <a:t>    </a:t>
-            </a:r>
-            <a:r>
-              <a:rPr lang="en-US" b="1" dirty="0"/>
-              <a:t>assert</a:t>
-            </a:r>
-            <a:r>
-              <a:rPr lang="en-US" dirty="0"/>
-              <a:t> 0≤k&lt;</a:t>
-            </a:r>
-            <a:r>
-              <a:rPr lang="en-US" dirty="0">
-                <a:sym typeface="Symbol"/>
-              </a:rPr>
-              <a:t>#a ; </a:t>
-            </a:r>
-            <a:br>
-              <a:rPr lang="en-US" dirty="0">
-                <a:sym typeface="Symbol"/>
-              </a:rPr>
-            </a:br>
-            <a:r>
-              <a:rPr lang="en-US" dirty="0">
-                <a:sym typeface="Symbol"/>
-              </a:rPr>
-              <a:t>    </a:t>
-            </a:r>
-            <a:r>
-              <a:rPr lang="en-US" b="1" dirty="0">
-                <a:sym typeface="Symbol"/>
-              </a:rPr>
-              <a:t>assert</a:t>
-            </a:r>
-            <a:r>
-              <a:rPr lang="en-US" dirty="0">
-                <a:sym typeface="Symbol"/>
-              </a:rPr>
-              <a:t> y≠0 ; </a:t>
-            </a:r>
-            <a:br>
-              <a:rPr lang="en-US" dirty="0">
-                <a:sym typeface="Symbol"/>
-              </a:rPr>
-            </a:br>
-            <a:r>
-              <a:rPr lang="en-US" dirty="0"/>
-              <a:t>    x := a[k]/y  ;</a:t>
-            </a:r>
-          </a:p>
-          <a:p>
-            <a:pPr marL="0" indent="0">
-              <a:buNone/>
-            </a:pPr>
-            <a:endParaRPr lang="en-US" dirty="0"/>
-          </a:p>
-          <a:p>
-            <a:r>
-              <a:rPr lang="en-US" dirty="0"/>
-              <a:t>Similar situation with guards in </a:t>
-            </a:r>
-            <a:r>
-              <a:rPr lang="en-US" dirty="0" err="1"/>
-              <a:t>ite</a:t>
-            </a:r>
-            <a:r>
-              <a:rPr lang="en-US" dirty="0"/>
-              <a:t> and loop.</a:t>
-            </a:r>
-          </a:p>
-          <a:p>
-            <a:endParaRPr lang="en-US" dirty="0"/>
-          </a:p>
-          <a:p>
-            <a:endParaRPr lang="en-US" dirty="0"/>
+              <a:rPr lang="en-US" sz="2400" dirty="0"/>
+              <a:t>Exception introduces non-standard flow of execution, which are often error prone, hence it is a good idea to verify exceptional flows.</a:t>
+            </a:r>
+          </a:p>
+          <a:p>
+            <a:r>
+              <a:rPr lang="en-US" sz="2400" dirty="0"/>
+              <a:t>The problem is, exception can be thrown from many points in the program</a:t>
+            </a:r>
+            <a:r>
+              <a:rPr lang="en-US" dirty="0"/>
+              <a:t> </a:t>
+            </a:r>
+            <a:r>
+              <a:rPr lang="en-US" dirty="0">
+                <a:sym typeface="Wingdings" pitchFamily="2" charset="2"/>
+              </a:rPr>
+              <a:t> </a:t>
+            </a:r>
+            <a:r>
+              <a:rPr lang="en-US" sz="2400" dirty="0"/>
+              <a:t>exploding the number or the size of the formulas that we have to deal with for verification.</a:t>
+            </a:r>
+          </a:p>
+          <a:p>
+            <a:r>
+              <a:rPr lang="en-US" sz="2400" dirty="0"/>
+              <a:t>But first ... how to deal with exception in Hoare logic / </a:t>
+            </a:r>
+            <a:r>
+              <a:rPr lang="en-US" sz="2400" b="1" dirty="0" err="1"/>
+              <a:t>wlp</a:t>
+            </a:r>
+            <a:r>
+              <a:rPr lang="en-US" sz="2400" dirty="0"/>
+              <a:t> ?</a:t>
+            </a:r>
+          </a:p>
+          <a:p>
+            <a:pPr lvl="1"/>
+            <a:r>
+              <a:rPr lang="en-US" sz="2000" dirty="0"/>
+              <a:t>Approach-1: extend post-condition to be a pair (</a:t>
+            </a:r>
+            <a:r>
+              <a:rPr lang="en-US" sz="2000" i="1" dirty="0" err="1"/>
+              <a:t>Q</a:t>
+            </a:r>
+            <a:r>
+              <a:rPr lang="en-US" sz="2000" baseline="-25000" dirty="0" err="1"/>
+              <a:t>n</a:t>
+            </a:r>
+            <a:r>
+              <a:rPr lang="en-US" sz="2000" dirty="0" err="1"/>
+              <a:t>,</a:t>
+            </a:r>
+            <a:r>
+              <a:rPr lang="en-US" sz="2000" i="1" dirty="0" err="1"/>
+              <a:t>Q</a:t>
+            </a:r>
+            <a:r>
+              <a:rPr lang="en-US" sz="2000" baseline="-25000" dirty="0" err="1"/>
+              <a:t>e</a:t>
+            </a:r>
+            <a:r>
+              <a:rPr lang="en-US" sz="2000" dirty="0"/>
+              <a:t>) representing the desired situation when a program terminates normally, and when it terminates exceptionally.</a:t>
+            </a:r>
+          </a:p>
+          <a:p>
+            <a:pPr lvl="1"/>
+            <a:r>
+              <a:rPr lang="en-US" dirty="0"/>
+              <a:t>Approach-2: figure out the jumps e.g. by first constructing the program’s a control flow graph</a:t>
+            </a:r>
+            <a:endParaRPr lang="en-US" sz="2000" dirty="0"/>
+          </a:p>
+          <a:p>
+            <a:endParaRPr lang="en-US" sz="2400" dirty="0"/>
           </a:p>
         </p:txBody>
       </p:sp>
@@ -40846,7 +40147,7 @@
     </p:spTree>
     <p:extLst>
       <p:ext uri="{BB962C8B-B14F-4D97-AF65-F5344CB8AC3E}">
-        <p14:creationId xmlns:p14="http://schemas.microsoft.com/office/powerpoint/2010/main" val="229356205"/>
+        <p14:creationId xmlns:p14="http://schemas.microsoft.com/office/powerpoint/2010/main" val="295763964"/>
       </p:ext>
     </p:extLst>
   </p:cSld>
@@ -40890,7 +40191,7 @@
           <a:p>
             <a:r>
               <a:rPr lang="en-US" dirty="0"/>
-              <a:t>Assignments and guards</a:t>
+              <a:t>Approach 1 </a:t>
             </a:r>
           </a:p>
         </p:txBody>
@@ -40907,17 +40208,19 @@
         </p:nvSpPr>
         <p:spPr>
           <a:xfrm>
-            <a:off x="500034" y="1447800"/>
-            <a:ext cx="8643966" cy="4572000"/>
+            <a:off x="685800" y="1383957"/>
+            <a:ext cx="7772400" cy="5109440"/>
           </a:xfrm>
         </p:spPr>
         <p:txBody>
-          <a:bodyPr/>
+          <a:bodyPr>
+            <a:normAutofit/>
+          </a:bodyPr>
           <a:lstStyle/>
           <a:p>
             <a:r>
               <a:rPr lang="en-US" dirty="0"/>
-              <a:t>Or we model exception throwing executions.  E.g. :</a:t>
+              <a:t>Extend the post-condition from a single predicate to a pair of predicate:</a:t>
             </a:r>
             <a:br>
               <a:rPr lang="en-US" dirty="0"/>
@@ -40927,142 +40230,346 @@
             </a:br>
             <a:r>
               <a:rPr lang="en-US" dirty="0"/>
-              <a:t>                x := a[k]/y</a:t>
-            </a:r>
-            <a:br>
-              <a:rPr lang="en-US" dirty="0"/>
-            </a:br>
-            <a:br>
-              <a:rPr lang="en-US" dirty="0"/>
-            </a:br>
-            <a:r>
-              <a:rPr lang="en-US" dirty="0"/>
-              <a:t>is then transformed to  :</a:t>
-            </a:r>
-            <a:br>
-              <a:rPr lang="en-US" dirty="0"/>
-            </a:br>
-            <a:r>
-              <a:rPr lang="en-US" dirty="0"/>
-              <a:t>    </a:t>
+              <a:t>{P}  S {Q,R}  where Q describes the expectation when S terminates normally, and R the expectation when S terminates by exception.</a:t>
+            </a:r>
+          </a:p>
+          <a:p>
+            <a:r>
+              <a:rPr lang="en-US" b="1" dirty="0" err="1">
+                <a:solidFill>
+                  <a:srgbClr val="FF0000"/>
+                </a:solidFill>
+              </a:rPr>
+              <a:t>wlp</a:t>
+            </a:r>
+            <a:r>
+              <a:rPr lang="en-US" dirty="0">
+                <a:solidFill>
+                  <a:srgbClr val="FF0000"/>
+                </a:solidFill>
+              </a:rPr>
+              <a:t> </a:t>
+            </a:r>
+            <a:r>
+              <a:rPr lang="en-US" dirty="0"/>
+              <a:t>(</a:t>
+            </a:r>
+            <a:r>
+              <a:rPr lang="en-US" i="1" dirty="0"/>
+              <a:t>x</a:t>
+            </a:r>
+            <a:r>
+              <a:rPr lang="en-US" dirty="0"/>
+              <a:t> := </a:t>
+            </a:r>
+            <a:r>
+              <a:rPr lang="en-US" i="1" dirty="0"/>
+              <a:t>e</a:t>
+            </a:r>
+            <a:r>
+              <a:rPr lang="en-US" dirty="0"/>
+              <a:t>) (</a:t>
+            </a:r>
+            <a:r>
+              <a:rPr lang="en-US" i="1" dirty="0"/>
+              <a:t>Q,R</a:t>
+            </a:r>
+            <a:r>
+              <a:rPr lang="en-US" dirty="0"/>
+              <a:t>) =  </a:t>
+            </a:r>
+            <a:r>
+              <a:rPr lang="en-US" i="1" dirty="0"/>
+              <a:t>Q</a:t>
+            </a:r>
+            <a:r>
+              <a:rPr lang="en-US" dirty="0"/>
+              <a:t>[</a:t>
+            </a:r>
+            <a:r>
+              <a:rPr lang="en-US" i="1" dirty="0"/>
+              <a:t>e/x</a:t>
+            </a:r>
+            <a:r>
+              <a:rPr lang="en-US" dirty="0"/>
+              <a:t>]     </a:t>
+            </a:r>
+            <a:r>
+              <a:rPr lang="en-US" sz="1400" dirty="0"/>
+              <a:t>-- assuming e does not throw an exception.</a:t>
+            </a:r>
+          </a:p>
+          <a:p>
+            <a:r>
+              <a:rPr lang="en-US" b="1" dirty="0" err="1">
+                <a:solidFill>
+                  <a:srgbClr val="FF0000"/>
+                </a:solidFill>
+              </a:rPr>
+              <a:t>wlp</a:t>
+            </a:r>
+            <a:r>
+              <a:rPr lang="en-US" b="1" dirty="0">
+                <a:solidFill>
+                  <a:srgbClr val="FF0000"/>
+                </a:solidFill>
+              </a:rPr>
+              <a:t> </a:t>
             </a:r>
             <a:r>
               <a:rPr lang="en-US" b="1" dirty="0"/>
-              <a:t>if</a:t>
-            </a:r>
-            <a:r>
-              <a:rPr lang="en-US" dirty="0"/>
-              <a:t> k</a:t>
-            </a:r>
-            <a:r>
-              <a:rPr lang="en-US" dirty="0">
-                <a:sym typeface="Symbol"/>
-              </a:rPr>
-              <a:t>&lt;0 \/ k#a  </a:t>
-            </a:r>
-            <a:r>
-              <a:rPr lang="en-US" b="1" dirty="0">
-                <a:sym typeface="Symbol"/>
-              </a:rPr>
-              <a:t>then</a:t>
-            </a:r>
-            <a:r>
-              <a:rPr lang="en-US" dirty="0">
-                <a:sym typeface="Symbol"/>
+              <a:t>raise</a:t>
+            </a:r>
+            <a:r>
+              <a:rPr lang="en-US" dirty="0"/>
+              <a:t> (</a:t>
+            </a:r>
+            <a:r>
+              <a:rPr lang="en-US" i="1" dirty="0"/>
+              <a:t>Q,R</a:t>
+            </a:r>
+            <a:r>
+              <a:rPr lang="en-US" dirty="0"/>
+              <a:t>)     =  </a:t>
+            </a:r>
+            <a:r>
+              <a:rPr lang="en-US" i="1" dirty="0"/>
+              <a:t>R</a:t>
+            </a:r>
+          </a:p>
+          <a:p>
+            <a:r>
+              <a:rPr lang="en-US" b="1" dirty="0" err="1">
+                <a:solidFill>
+                  <a:srgbClr val="FF0000"/>
+                </a:solidFill>
+              </a:rPr>
+              <a:t>wlp</a:t>
+            </a:r>
+            <a:r>
+              <a:rPr lang="en-US" dirty="0">
+                <a:solidFill>
+                  <a:srgbClr val="FF0000"/>
+                </a:solidFill>
               </a:rPr>
               <a:t> </a:t>
             </a:r>
             <a:r>
-              <a:rPr lang="en-US" b="1" dirty="0">
-                <a:sym typeface="Symbol"/>
-              </a:rPr>
-              <a:t>raise</a:t>
-            </a:r>
-            <a:r>
-              <a:rPr lang="en-US" dirty="0">
-                <a:sym typeface="Symbol"/>
-              </a:rPr>
+              <a:rPr lang="en-US" dirty="0"/>
+              <a:t>(</a:t>
+            </a:r>
+            <a:r>
+              <a:rPr lang="en-US" i="1" dirty="0"/>
+              <a:t>S</a:t>
+            </a:r>
+            <a:r>
+              <a:rPr lang="en-US" baseline="-25000" dirty="0"/>
+              <a:t>1</a:t>
+            </a:r>
+            <a:r>
+              <a:rPr lang="en-US" dirty="0"/>
               <a:t> ; </a:t>
             </a:r>
-            <a:br>
-              <a:rPr lang="en-US" dirty="0">
-                <a:sym typeface="Symbol"/>
-              </a:rPr>
-            </a:br>
-            <a:r>
-              <a:rPr lang="en-US" dirty="0">
-                <a:sym typeface="Symbol"/>
-              </a:rPr>
-              <a:t>    </a:t>
-            </a:r>
-            <a:r>
-              <a:rPr lang="en-US" b="1" dirty="0">
-                <a:sym typeface="Symbol"/>
-              </a:rPr>
-              <a:t>if</a:t>
-            </a:r>
-            <a:r>
-              <a:rPr lang="en-US" dirty="0">
-                <a:sym typeface="Symbol"/>
-              </a:rPr>
-              <a:t> y=0                </a:t>
-            </a:r>
-            <a:r>
-              <a:rPr lang="en-US" b="1" dirty="0">
-                <a:sym typeface="Symbol"/>
-              </a:rPr>
-              <a:t>then</a:t>
-            </a:r>
-            <a:r>
-              <a:rPr lang="en-US" dirty="0">
-                <a:sym typeface="Symbol"/>
-              </a:rPr>
+            <a:r>
+              <a:rPr lang="en-US" i="1" dirty="0"/>
+              <a:t>S</a:t>
+            </a:r>
+            <a:r>
+              <a:rPr lang="en-US" baseline="-25000" dirty="0"/>
+              <a:t>2</a:t>
+            </a:r>
+            <a:r>
+              <a:rPr lang="en-US" dirty="0"/>
+              <a:t>) (</a:t>
+            </a:r>
+            <a:r>
+              <a:rPr lang="en-US" i="1" dirty="0"/>
+              <a:t>Q,R</a:t>
+            </a:r>
+            <a:r>
+              <a:rPr lang="en-US" dirty="0"/>
+              <a:t>) =  </a:t>
+            </a:r>
+            <a:r>
+              <a:rPr lang="en-US" b="1" dirty="0" err="1">
+                <a:solidFill>
+                  <a:srgbClr val="FF0000"/>
+                </a:solidFill>
+              </a:rPr>
+              <a:t>wlp</a:t>
+            </a:r>
+            <a:r>
+              <a:rPr lang="en-US" dirty="0"/>
               <a:t> </a:t>
             </a:r>
             <a:r>
-              <a:rPr lang="en-US" b="1" dirty="0">
-                <a:sym typeface="Symbol"/>
-              </a:rPr>
-              <a:t>raise</a:t>
-            </a:r>
-            <a:r>
-              <a:rPr lang="en-US" dirty="0">
-                <a:sym typeface="Symbol"/>
-              </a:rPr>
-              <a:t> ; </a:t>
-            </a:r>
-            <a:br>
-              <a:rPr lang="en-US" dirty="0">
-                <a:sym typeface="Symbol"/>
-              </a:rPr>
-            </a:br>
-            <a:r>
-              <a:rPr lang="en-US" dirty="0"/>
-              <a:t>    x := a[k]/y  ;</a:t>
-            </a:r>
-          </a:p>
-          <a:p>
-            <a:endParaRPr lang="en-US" dirty="0"/>
-          </a:p>
-          <a:p>
-            <a:r>
-              <a:rPr lang="en-US" dirty="0"/>
-              <a:t>Similar situation with guards in </a:t>
+              <a:rPr lang="en-US" i="1" dirty="0"/>
+              <a:t>S</a:t>
+            </a:r>
+            <a:r>
+              <a:rPr lang="en-US" baseline="-25000" dirty="0"/>
+              <a:t>1</a:t>
+            </a:r>
+            <a:r>
+              <a:rPr lang="en-US" dirty="0"/>
+              <a:t> (</a:t>
+            </a:r>
+            <a:r>
+              <a:rPr lang="en-US" b="1" dirty="0" err="1">
+                <a:solidFill>
+                  <a:srgbClr val="FF0000"/>
+                </a:solidFill>
+              </a:rPr>
+              <a:t>wlp</a:t>
+            </a:r>
+            <a:r>
+              <a:rPr lang="en-US" dirty="0"/>
+              <a:t> </a:t>
+            </a:r>
+            <a:r>
+              <a:rPr lang="en-US" i="1" dirty="0"/>
+              <a:t>S</a:t>
+            </a:r>
+            <a:r>
+              <a:rPr lang="en-US" baseline="-25000" dirty="0"/>
+              <a:t>2</a:t>
+            </a:r>
+            <a:r>
+              <a:rPr lang="en-US" dirty="0"/>
+              <a:t> (</a:t>
+            </a:r>
+            <a:r>
+              <a:rPr lang="en-US" i="1" dirty="0"/>
+              <a:t>Q</a:t>
+            </a:r>
+            <a:r>
+              <a:rPr lang="en-US" dirty="0"/>
+              <a:t>,</a:t>
+            </a:r>
+            <a:r>
+              <a:rPr lang="en-US" i="1" dirty="0"/>
+              <a:t>R</a:t>
+            </a:r>
+            <a:r>
+              <a:rPr lang="en-US" dirty="0"/>
+              <a:t>), </a:t>
+            </a:r>
+            <a:r>
+              <a:rPr lang="en-US" i="1" dirty="0"/>
+              <a:t>R</a:t>
+            </a:r>
+            <a:r>
+              <a:rPr lang="en-US" dirty="0"/>
+              <a:t>)</a:t>
+            </a:r>
+          </a:p>
+          <a:p>
+            <a:r>
+              <a:rPr lang="en-US" b="1" dirty="0" err="1">
+                <a:solidFill>
+                  <a:srgbClr val="FF0000"/>
+                </a:solidFill>
+              </a:rPr>
+              <a:t>wlp</a:t>
+            </a:r>
+            <a:r>
+              <a:rPr lang="en-US" dirty="0">
+                <a:solidFill>
+                  <a:srgbClr val="FF0000"/>
+                </a:solidFill>
+              </a:rPr>
+              <a:t> </a:t>
+            </a:r>
+            <a:r>
+              <a:rPr lang="en-US" dirty="0"/>
+              <a:t>(</a:t>
+            </a:r>
+            <a:r>
+              <a:rPr lang="en-US" i="1" dirty="0"/>
+              <a:t>S</a:t>
+            </a:r>
+            <a:r>
+              <a:rPr lang="en-US" dirty="0"/>
+              <a:t> ! </a:t>
+            </a:r>
+            <a:r>
+              <a:rPr lang="en-US" i="1" dirty="0"/>
+              <a:t>H</a:t>
+            </a:r>
+            <a:r>
+              <a:rPr lang="en-US" dirty="0"/>
+              <a:t>) (</a:t>
+            </a:r>
+            <a:r>
+              <a:rPr lang="en-US" i="1" dirty="0"/>
+              <a:t>Q,R</a:t>
+            </a:r>
+            <a:r>
+              <a:rPr lang="en-US" dirty="0"/>
+              <a:t>)   =  </a:t>
+            </a:r>
+            <a:r>
+              <a:rPr lang="en-US" b="1" dirty="0" err="1">
+                <a:solidFill>
+                  <a:srgbClr val="FF0000"/>
+                </a:solidFill>
+              </a:rPr>
+              <a:t>wlp</a:t>
+            </a:r>
+            <a:r>
+              <a:rPr lang="en-US" dirty="0"/>
+              <a:t>  S  (</a:t>
+            </a:r>
+            <a:r>
+              <a:rPr lang="en-US" i="1" dirty="0"/>
+              <a:t>Q</a:t>
+            </a:r>
+            <a:r>
+              <a:rPr lang="en-US" dirty="0"/>
+              <a:t> ,  </a:t>
+            </a:r>
+            <a:r>
+              <a:rPr lang="en-US" b="1" dirty="0" err="1">
+                <a:solidFill>
+                  <a:srgbClr val="FF0000"/>
+                </a:solidFill>
+              </a:rPr>
+              <a:t>wlp</a:t>
+            </a:r>
+            <a:r>
+              <a:rPr lang="en-US" dirty="0"/>
+              <a:t>  </a:t>
+            </a:r>
+            <a:r>
+              <a:rPr lang="en-US" i="1" dirty="0"/>
+              <a:t>H</a:t>
+            </a:r>
+            <a:r>
+              <a:rPr lang="en-US" dirty="0"/>
+              <a:t>  (</a:t>
+            </a:r>
+            <a:r>
+              <a:rPr lang="en-US" i="1" dirty="0"/>
+              <a:t>Q,R</a:t>
+            </a:r>
+            <a:r>
+              <a:rPr lang="en-US" dirty="0"/>
+              <a:t>))</a:t>
+            </a:r>
+          </a:p>
+          <a:p>
+            <a:r>
+              <a:rPr lang="en-US" dirty="0"/>
+              <a:t>This avoids blow up that we saw in Approach-1, but on the other hand </a:t>
             </a:r>
             <a:r>
               <a:rPr lang="en-US" dirty="0" err="1"/>
-              <a:t>ite</a:t>
-            </a:r>
-            <a:r>
-              <a:rPr lang="en-US" dirty="0"/>
-              <a:t> and loop.</a:t>
-            </a:r>
-          </a:p>
-          <a:p>
-            <a:endParaRPr lang="en-US" dirty="0"/>
-          </a:p>
-          <a:p>
-            <a:endParaRPr lang="en-US" dirty="0"/>
+              <a:t>wlp</a:t>
+            </a:r>
+            <a:r>
+              <a:rPr lang="en-US" dirty="0"/>
+              <a:t> becomes more complicated.</a:t>
+            </a:r>
           </a:p>
         </p:txBody>
       </p:sp>
@@ -41084,7 +40591,7 @@
             <a:pPr>
               <a:defRPr/>
             </a:pPr>
-            <a:fld id="{848220AE-4ABF-4647-9677-DBC7878747C7}" type="slidenum">
+            <a:fld id="{58A332FB-769C-4CBB-BDDE-0DC26211CC04}" type="slidenum">
               <a:rPr lang="en-US" smtClean="0"/>
               <a:pPr>
                 <a:defRPr/>
@@ -41098,7 +40605,7 @@
     </p:spTree>
     <p:extLst>
       <p:ext uri="{BB962C8B-B14F-4D97-AF65-F5344CB8AC3E}">
-        <p14:creationId xmlns:p14="http://schemas.microsoft.com/office/powerpoint/2010/main" val="1970082773"/>
+        <p14:creationId xmlns:p14="http://schemas.microsoft.com/office/powerpoint/2010/main" val="199937732"/>
       </p:ext>
     </p:extLst>
   </p:cSld>
@@ -41127,7 +40634,13 @@
       </p:grpSpPr>
       <p:sp>
         <p:nvSpPr>
-          <p:cNvPr id="2" name="Title 1"/>
+          <p:cNvPr id="2" name="Title 1">
+            <a:extLst>
+              <a:ext uri="{FF2B5EF4-FFF2-40B4-BE49-F238E27FC236}">
+                <a16:creationId xmlns:a16="http://schemas.microsoft.com/office/drawing/2014/main" id="{F33222F6-95E6-71E4-0B13-4DF2E9B0DA97}"/>
+              </a:ext>
+            </a:extLst>
+          </p:cNvPr>
           <p:cNvSpPr>
             <a:spLocks noGrp="1"/>
           </p:cNvSpPr>
@@ -41141,126 +40654,21 @@
           <a:lstStyle/>
           <a:p>
             <a:r>
-              <a:rPr lang="en-US" dirty="0"/>
-              <a:t>Exception handler</a:t>
-            </a:r>
-          </a:p>
-        </p:txBody>
-      </p:sp>
-      <p:sp>
-        <p:nvSpPr>
-          <p:cNvPr id="3" name="Content Placeholder 2"/>
-          <p:cNvSpPr>
-            <a:spLocks noGrp="1"/>
-          </p:cNvSpPr>
-          <p:nvPr>
-            <p:ph idx="1"/>
-          </p:nvPr>
-        </p:nvSpPr>
-        <p:spPr/>
-        <p:txBody>
-          <a:bodyPr/>
-          <a:lstStyle/>
-          <a:p>
-            <a:r>
-              <a:rPr lang="en-US" dirty="0"/>
-              <a:t>S ! H  (</a:t>
-            </a:r>
-            <a:r>
-              <a:rPr lang="en-US" b="1" dirty="0"/>
-              <a:t>try</a:t>
-            </a:r>
-            <a:r>
-              <a:rPr lang="en-US" dirty="0"/>
-              <a:t> S </a:t>
-            </a:r>
-            <a:r>
-              <a:rPr lang="en-US" b="1" dirty="0"/>
-              <a:t>catch</a:t>
-            </a:r>
-            <a:r>
-              <a:rPr lang="en-US" dirty="0"/>
-              <a:t> H)</a:t>
-            </a:r>
-            <a:br>
-              <a:rPr lang="en-US" dirty="0"/>
-            </a:br>
-            <a:br>
-              <a:rPr lang="en-US" dirty="0"/>
-            </a:br>
-            <a:r>
-              <a:rPr lang="en-US" dirty="0"/>
-              <a:t>is treated as:</a:t>
-            </a:r>
-            <a:br>
-              <a:rPr lang="en-US" dirty="0"/>
-            </a:br>
-            <a:br>
-              <a:rPr lang="en-US" dirty="0"/>
-            </a:br>
-            <a:r>
-              <a:rPr lang="en-US" dirty="0"/>
-              <a:t>S ; </a:t>
-            </a:r>
-            <a:r>
-              <a:rPr lang="en-US" b="1" dirty="0"/>
-              <a:t>if</a:t>
-            </a:r>
-            <a:r>
-              <a:rPr lang="en-US" dirty="0"/>
-              <a:t> </a:t>
-            </a:r>
-            <a:r>
-              <a:rPr lang="en-US" dirty="0" err="1"/>
-              <a:t>exc</a:t>
-            </a:r>
-            <a:r>
-              <a:rPr lang="en-US" dirty="0"/>
-              <a:t> </a:t>
-            </a:r>
-            <a:r>
-              <a:rPr lang="en-US" b="1" dirty="0"/>
-              <a:t>then</a:t>
-            </a:r>
-            <a:r>
-              <a:rPr lang="en-US" dirty="0"/>
-              <a:t> { </a:t>
-            </a:r>
-            <a:r>
-              <a:rPr lang="en-US" dirty="0" err="1"/>
-              <a:t>exc</a:t>
-            </a:r>
-            <a:r>
-              <a:rPr lang="en-US" dirty="0"/>
-              <a:t>:=false ; H } </a:t>
-            </a:r>
-            <a:r>
-              <a:rPr lang="en-US" b="1" dirty="0"/>
-              <a:t>else</a:t>
-            </a:r>
-            <a:r>
-              <a:rPr lang="en-US" dirty="0"/>
-              <a:t> skip</a:t>
-            </a:r>
-            <a:br>
-              <a:rPr lang="en-US" dirty="0"/>
-            </a:br>
-            <a:br>
-              <a:rPr lang="en-US" dirty="0"/>
-            </a:br>
-            <a:r>
-              <a:rPr lang="en-US" sz="1800" dirty="0"/>
-              <a:t>(“;” should not be expanded here)</a:t>
-            </a:r>
-          </a:p>
-          <a:p>
-            <a:endParaRPr lang="en-US" sz="1800" dirty="0"/>
-          </a:p>
-        </p:txBody>
-      </p:sp>
-      <p:sp>
-        <p:nvSpPr>
-          <p:cNvPr id="4" name="Slide Number Placeholder 3"/>
+              <a:rPr lang="en-NL" dirty="0"/>
+              <a:t>Approach 2: via a CFG</a:t>
+            </a:r>
+          </a:p>
+        </p:txBody>
+      </p:sp>
+      <p:sp>
+        <p:nvSpPr>
+          <p:cNvPr id="4" name="Slide Number Placeholder 3">
+            <a:extLst>
+              <a:ext uri="{FF2B5EF4-FFF2-40B4-BE49-F238E27FC236}">
+                <a16:creationId xmlns:a16="http://schemas.microsoft.com/office/drawing/2014/main" id="{60950ABB-7D69-6FE4-0842-DC27831020CA}"/>
+              </a:ext>
+            </a:extLst>
+          </p:cNvPr>
           <p:cNvSpPr>
             <a:spLocks noGrp="1"/>
           </p:cNvSpPr>
@@ -41276,7 +40684,7 @@
             <a:pPr>
               <a:defRPr/>
             </a:pPr>
-            <a:fld id="{848220AE-4ABF-4647-9677-DBC7878747C7}" type="slidenum">
+            <a:fld id="{58A332FB-769C-4CBB-BDDE-0DC26211CC04}" type="slidenum">
               <a:rPr lang="en-US" smtClean="0"/>
               <a:pPr>
                 <a:defRPr/>
@@ -41287,10 +40695,844 @@
           </a:p>
         </p:txBody>
       </p:sp>
+      <p:sp>
+        <p:nvSpPr>
+          <p:cNvPr id="5" name="TextBox 4">
+            <a:extLst>
+              <a:ext uri="{FF2B5EF4-FFF2-40B4-BE49-F238E27FC236}">
+                <a16:creationId xmlns:a16="http://schemas.microsoft.com/office/drawing/2014/main" id="{7DA9BA26-029A-191B-E200-7DB3E4DD2B3A}"/>
+              </a:ext>
+            </a:extLst>
+          </p:cNvPr>
+          <p:cNvSpPr txBox="1"/>
+          <p:nvPr/>
+        </p:nvSpPr>
+        <p:spPr>
+          <a:xfrm>
+            <a:off x="293386" y="1859340"/>
+            <a:ext cx="3748142" cy="1569660"/>
+          </a:xfrm>
+          <a:prstGeom prst="rect">
+            <a:avLst/>
+          </a:prstGeom>
+          <a:noFill/>
+          <a:ln>
+            <a:solidFill>
+              <a:schemeClr val="tx1"/>
+            </a:solidFill>
+          </a:ln>
+        </p:spPr>
+        <p:txBody>
+          <a:bodyPr wrap="none" rtlCol="0">
+            <a:spAutoFit/>
+          </a:bodyPr>
+          <a:lstStyle/>
+          <a:p>
+            <a:pPr>
+              <a:buClr>
+                <a:schemeClr val="accent1">
+                  <a:lumMod val="75000"/>
+                </a:schemeClr>
+              </a:buClr>
+              <a:buSzPct val="85000"/>
+            </a:pPr>
+            <a:r>
+              <a:rPr lang="en-US" b="1" dirty="0"/>
+              <a:t>{ if</a:t>
+            </a:r>
+            <a:r>
+              <a:rPr lang="en-US" dirty="0"/>
+              <a:t> k</a:t>
+            </a:r>
+            <a:r>
+              <a:rPr lang="en-US" dirty="0">
+                <a:sym typeface="Symbol"/>
+              </a:rPr>
+              <a:t>&lt;0 \/ k#a  </a:t>
+            </a:r>
+            <a:r>
+              <a:rPr lang="en-US" b="1" dirty="0">
+                <a:sym typeface="Symbol"/>
+              </a:rPr>
+              <a:t>then</a:t>
+            </a:r>
+            <a:r>
+              <a:rPr lang="en-US" dirty="0">
+                <a:sym typeface="Symbol"/>
+              </a:rPr>
+              <a:t> </a:t>
+            </a:r>
+            <a:r>
+              <a:rPr lang="en-US" b="1" dirty="0">
+                <a:sym typeface="Symbol"/>
+              </a:rPr>
+              <a:t>raise</a:t>
+            </a:r>
+            <a:r>
+              <a:rPr lang="en-US" dirty="0">
+                <a:sym typeface="Symbol"/>
+              </a:rPr>
+              <a:t> ; </a:t>
+            </a:r>
+            <a:br>
+              <a:rPr lang="en-US" dirty="0">
+                <a:sym typeface="Symbol"/>
+              </a:rPr>
+            </a:br>
+            <a:r>
+              <a:rPr lang="en-US" dirty="0">
+                <a:sym typeface="Symbol"/>
+              </a:rPr>
+              <a:t>  </a:t>
+            </a:r>
+            <a:r>
+              <a:rPr lang="en-US" b="1" dirty="0">
+                <a:sym typeface="Symbol"/>
+              </a:rPr>
+              <a:t>if</a:t>
+            </a:r>
+            <a:r>
+              <a:rPr lang="en-US" dirty="0">
+                <a:sym typeface="Symbol"/>
+              </a:rPr>
+              <a:t> y=0              </a:t>
+            </a:r>
+            <a:r>
+              <a:rPr lang="en-US" b="1" dirty="0">
+                <a:sym typeface="Symbol"/>
+              </a:rPr>
+              <a:t>then</a:t>
+            </a:r>
+            <a:r>
+              <a:rPr lang="en-US" dirty="0">
+                <a:sym typeface="Symbol"/>
+              </a:rPr>
+              <a:t> </a:t>
+            </a:r>
+            <a:r>
+              <a:rPr lang="en-US" b="1" dirty="0">
+                <a:sym typeface="Symbol"/>
+              </a:rPr>
+              <a:t>raise</a:t>
+            </a:r>
+            <a:r>
+              <a:rPr lang="en-US" dirty="0">
+                <a:sym typeface="Symbol"/>
+              </a:rPr>
+              <a:t> ; </a:t>
+            </a:r>
+            <a:br>
+              <a:rPr lang="en-US" dirty="0">
+                <a:sym typeface="Symbol"/>
+              </a:rPr>
+            </a:br>
+            <a:r>
+              <a:rPr lang="en-US" dirty="0">
+                <a:sym typeface="Symbol"/>
+              </a:rPr>
+              <a:t>  </a:t>
+            </a:r>
+            <a:r>
+              <a:rPr lang="en-US" dirty="0"/>
+              <a:t>x := a[k]/y  }</a:t>
+            </a:r>
+            <a:br>
+              <a:rPr lang="en-US" dirty="0"/>
+            </a:br>
+            <a:r>
+              <a:rPr lang="en-US" dirty="0">
+                <a:highlight>
+                  <a:srgbClr val="FFFF00"/>
+                </a:highlight>
+              </a:rPr>
+              <a:t>! { x := -1 }</a:t>
+            </a:r>
+          </a:p>
+        </p:txBody>
+      </p:sp>
+      <p:sp>
+        <p:nvSpPr>
+          <p:cNvPr id="7" name="TextBox 6">
+            <a:extLst>
+              <a:ext uri="{FF2B5EF4-FFF2-40B4-BE49-F238E27FC236}">
+                <a16:creationId xmlns:a16="http://schemas.microsoft.com/office/drawing/2014/main" id="{DDD42E68-9F92-6968-8793-39489D4F1F35}"/>
+              </a:ext>
+            </a:extLst>
+          </p:cNvPr>
+          <p:cNvSpPr txBox="1"/>
+          <p:nvPr/>
+        </p:nvSpPr>
+        <p:spPr>
+          <a:xfrm>
+            <a:off x="5307958" y="2099257"/>
+            <a:ext cx="1755609" cy="461665"/>
+          </a:xfrm>
+          <a:prstGeom prst="rect">
+            <a:avLst/>
+          </a:prstGeom>
+          <a:solidFill>
+            <a:schemeClr val="accent5">
+              <a:lumMod val="20000"/>
+              <a:lumOff val="80000"/>
+            </a:schemeClr>
+          </a:solidFill>
+          <a:ln>
+            <a:solidFill>
+              <a:schemeClr val="accent1">
+                <a:lumMod val="75000"/>
+              </a:schemeClr>
+            </a:solidFill>
+          </a:ln>
+        </p:spPr>
+        <p:txBody>
+          <a:bodyPr wrap="none" rtlCol="0">
+            <a:spAutoFit/>
+          </a:bodyPr>
+          <a:lstStyle/>
+          <a:p>
+            <a:r>
+              <a:rPr lang="en-US" dirty="0"/>
+              <a:t> k</a:t>
+            </a:r>
+            <a:r>
+              <a:rPr lang="en-US" dirty="0">
+                <a:sym typeface="Symbol"/>
+              </a:rPr>
+              <a:t>&lt;0 \/ k#a </a:t>
+            </a:r>
+            <a:endParaRPr lang="en-NL" dirty="0"/>
+          </a:p>
+        </p:txBody>
+      </p:sp>
+      <p:sp>
+        <p:nvSpPr>
+          <p:cNvPr id="8" name="TextBox 7">
+            <a:extLst>
+              <a:ext uri="{FF2B5EF4-FFF2-40B4-BE49-F238E27FC236}">
+                <a16:creationId xmlns:a16="http://schemas.microsoft.com/office/drawing/2014/main" id="{22B70340-D0CD-A058-65C4-44D9FA79959B}"/>
+              </a:ext>
+            </a:extLst>
+          </p:cNvPr>
+          <p:cNvSpPr txBox="1"/>
+          <p:nvPr/>
+        </p:nvSpPr>
+        <p:spPr>
+          <a:xfrm>
+            <a:off x="5814506" y="2875120"/>
+            <a:ext cx="742511" cy="461665"/>
+          </a:xfrm>
+          <a:prstGeom prst="rect">
+            <a:avLst/>
+          </a:prstGeom>
+          <a:solidFill>
+            <a:schemeClr val="accent5">
+              <a:lumMod val="20000"/>
+              <a:lumOff val="80000"/>
+            </a:schemeClr>
+          </a:solidFill>
+          <a:ln>
+            <a:solidFill>
+              <a:schemeClr val="accent1">
+                <a:lumMod val="75000"/>
+              </a:schemeClr>
+            </a:solidFill>
+          </a:ln>
+        </p:spPr>
+        <p:txBody>
+          <a:bodyPr wrap="none" rtlCol="0">
+            <a:spAutoFit/>
+          </a:bodyPr>
+          <a:lstStyle/>
+          <a:p>
+            <a:r>
+              <a:rPr lang="en-US" dirty="0"/>
+              <a:t> y=0</a:t>
+            </a:r>
+            <a:endParaRPr lang="en-NL" dirty="0"/>
+          </a:p>
+        </p:txBody>
+      </p:sp>
+      <p:sp>
+        <p:nvSpPr>
+          <p:cNvPr id="9" name="TextBox 8">
+            <a:extLst>
+              <a:ext uri="{FF2B5EF4-FFF2-40B4-BE49-F238E27FC236}">
+                <a16:creationId xmlns:a16="http://schemas.microsoft.com/office/drawing/2014/main" id="{9266A8C3-BF49-E6D0-00D9-089855950710}"/>
+              </a:ext>
+            </a:extLst>
+          </p:cNvPr>
+          <p:cNvSpPr txBox="1"/>
+          <p:nvPr/>
+        </p:nvSpPr>
+        <p:spPr>
+          <a:xfrm>
+            <a:off x="5366466" y="3648173"/>
+            <a:ext cx="1638590" cy="461665"/>
+          </a:xfrm>
+          <a:prstGeom prst="rect">
+            <a:avLst/>
+          </a:prstGeom>
+          <a:solidFill>
+            <a:srgbClr val="00B0F0">
+              <a:alpha val="43922"/>
+            </a:srgbClr>
+          </a:solidFill>
+          <a:ln>
+            <a:solidFill>
+              <a:schemeClr val="accent1">
+                <a:lumMod val="75000"/>
+              </a:schemeClr>
+            </a:solidFill>
+          </a:ln>
+        </p:spPr>
+        <p:txBody>
+          <a:bodyPr wrap="none" rtlCol="0">
+            <a:spAutoFit/>
+          </a:bodyPr>
+          <a:lstStyle/>
+          <a:p>
+            <a:r>
+              <a:rPr lang="en-US" dirty="0">
+                <a:sym typeface="Symbol"/>
+              </a:rPr>
+              <a:t> </a:t>
+            </a:r>
+            <a:r>
+              <a:rPr lang="en-US" dirty="0"/>
+              <a:t>x := a[k]/y </a:t>
+            </a:r>
+            <a:endParaRPr lang="en-NL" dirty="0"/>
+          </a:p>
+        </p:txBody>
+      </p:sp>
+      <p:sp>
+        <p:nvSpPr>
+          <p:cNvPr id="10" name="TextBox 9">
+            <a:extLst>
+              <a:ext uri="{FF2B5EF4-FFF2-40B4-BE49-F238E27FC236}">
+                <a16:creationId xmlns:a16="http://schemas.microsoft.com/office/drawing/2014/main" id="{617D355C-574B-4097-4DC5-F95AFA88F66A}"/>
+              </a:ext>
+            </a:extLst>
+          </p:cNvPr>
+          <p:cNvSpPr txBox="1"/>
+          <p:nvPr/>
+        </p:nvSpPr>
+        <p:spPr>
+          <a:xfrm>
+            <a:off x="7399395" y="2099256"/>
+            <a:ext cx="1083951" cy="461665"/>
+          </a:xfrm>
+          <a:prstGeom prst="rect">
+            <a:avLst/>
+          </a:prstGeom>
+          <a:solidFill>
+            <a:srgbClr val="FFFF00">
+              <a:alpha val="43922"/>
+            </a:srgbClr>
+          </a:solidFill>
+          <a:ln>
+            <a:solidFill>
+              <a:schemeClr val="accent1">
+                <a:lumMod val="75000"/>
+              </a:schemeClr>
+            </a:solidFill>
+          </a:ln>
+        </p:spPr>
+        <p:txBody>
+          <a:bodyPr wrap="none" rtlCol="0">
+            <a:spAutoFit/>
+          </a:bodyPr>
+          <a:lstStyle/>
+          <a:p>
+            <a:r>
+              <a:rPr lang="en-US" dirty="0">
+                <a:sym typeface="Symbol"/>
+              </a:rPr>
+              <a:t> </a:t>
+            </a:r>
+            <a:r>
+              <a:rPr lang="en-US" dirty="0"/>
+              <a:t>x := -1</a:t>
+            </a:r>
+            <a:endParaRPr lang="en-NL" dirty="0"/>
+          </a:p>
+        </p:txBody>
+      </p:sp>
+      <p:sp>
+        <p:nvSpPr>
+          <p:cNvPr id="12" name="Oval 11">
+            <a:extLst>
+              <a:ext uri="{FF2B5EF4-FFF2-40B4-BE49-F238E27FC236}">
+                <a16:creationId xmlns:a16="http://schemas.microsoft.com/office/drawing/2014/main" id="{190954A8-FA9C-A420-DB44-E7A75631877A}"/>
+              </a:ext>
+            </a:extLst>
+          </p:cNvPr>
+          <p:cNvSpPr/>
+          <p:nvPr/>
+        </p:nvSpPr>
+        <p:spPr>
+          <a:xfrm>
+            <a:off x="6005654" y="1488884"/>
+            <a:ext cx="360219" cy="381126"/>
+          </a:xfrm>
+          <a:prstGeom prst="ellipse">
+            <a:avLst/>
+          </a:prstGeom>
+          <a:solidFill>
+            <a:schemeClr val="bg1">
+              <a:lumMod val="50000"/>
+            </a:schemeClr>
+          </a:solidFill>
+          <a:ln>
+            <a:noFill/>
+          </a:ln>
+        </p:spPr>
+        <p:style>
+          <a:lnRef idx="2">
+            <a:schemeClr val="accent1">
+              <a:shade val="15000"/>
+            </a:schemeClr>
+          </a:lnRef>
+          <a:fillRef idx="1">
+            <a:schemeClr val="accent1"/>
+          </a:fillRef>
+          <a:effectRef idx="0">
+            <a:schemeClr val="accent1"/>
+          </a:effectRef>
+          <a:fontRef idx="minor">
+            <a:schemeClr val="lt1"/>
+          </a:fontRef>
+        </p:style>
+        <p:txBody>
+          <a:bodyPr rtlCol="0" anchor="ctr"/>
+          <a:lstStyle/>
+          <a:p>
+            <a:pPr algn="ctr"/>
+            <a:endParaRPr lang="en-NL"/>
+          </a:p>
+        </p:txBody>
+      </p:sp>
+      <p:cxnSp>
+        <p:nvCxnSpPr>
+          <p:cNvPr id="14" name="Elbow Connector 13">
+            <a:extLst>
+              <a:ext uri="{FF2B5EF4-FFF2-40B4-BE49-F238E27FC236}">
+                <a16:creationId xmlns:a16="http://schemas.microsoft.com/office/drawing/2014/main" id="{141B9255-AF3F-D3D3-0F88-CBE143303EB3}"/>
+              </a:ext>
+            </a:extLst>
+          </p:cNvPr>
+          <p:cNvCxnSpPr>
+            <a:stCxn id="12" idx="4"/>
+            <a:endCxn id="7" idx="0"/>
+          </p:cNvCxnSpPr>
+          <p:nvPr/>
+        </p:nvCxnSpPr>
+        <p:spPr>
+          <a:xfrm rot="5400000">
+            <a:off x="6071141" y="1984633"/>
+            <a:ext cx="229247" cy="1"/>
+          </a:xfrm>
+          <a:prstGeom prst="bentConnector3">
+            <a:avLst/>
+          </a:prstGeom>
+          <a:ln w="12700">
+            <a:solidFill>
+              <a:schemeClr val="tx1"/>
+            </a:solidFill>
+            <a:tailEnd type="triangle"/>
+          </a:ln>
+        </p:spPr>
+        <p:style>
+          <a:lnRef idx="1">
+            <a:schemeClr val="accent1"/>
+          </a:lnRef>
+          <a:fillRef idx="0">
+            <a:schemeClr val="accent1"/>
+          </a:fillRef>
+          <a:effectRef idx="0">
+            <a:schemeClr val="accent1"/>
+          </a:effectRef>
+          <a:fontRef idx="minor">
+            <a:schemeClr val="tx1"/>
+          </a:fontRef>
+        </p:style>
+      </p:cxnSp>
+      <p:cxnSp>
+        <p:nvCxnSpPr>
+          <p:cNvPr id="17" name="Elbow Connector 16">
+            <a:extLst>
+              <a:ext uri="{FF2B5EF4-FFF2-40B4-BE49-F238E27FC236}">
+                <a16:creationId xmlns:a16="http://schemas.microsoft.com/office/drawing/2014/main" id="{511C86C6-E616-4514-C86E-2D7D645081DF}"/>
+              </a:ext>
+            </a:extLst>
+          </p:cNvPr>
+          <p:cNvCxnSpPr>
+            <a:cxnSpLocks/>
+            <a:stCxn id="7" idx="2"/>
+            <a:endCxn id="8" idx="0"/>
+          </p:cNvCxnSpPr>
+          <p:nvPr/>
+        </p:nvCxnSpPr>
+        <p:spPr>
+          <a:xfrm rot="5400000">
+            <a:off x="6028664" y="2718021"/>
+            <a:ext cx="314198" cy="1"/>
+          </a:xfrm>
+          <a:prstGeom prst="bentConnector3">
+            <a:avLst/>
+          </a:prstGeom>
+          <a:ln w="12700">
+            <a:solidFill>
+              <a:schemeClr val="tx1"/>
+            </a:solidFill>
+            <a:tailEnd type="triangle"/>
+          </a:ln>
+        </p:spPr>
+        <p:style>
+          <a:lnRef idx="1">
+            <a:schemeClr val="accent1"/>
+          </a:lnRef>
+          <a:fillRef idx="0">
+            <a:schemeClr val="accent1"/>
+          </a:fillRef>
+          <a:effectRef idx="0">
+            <a:schemeClr val="accent1"/>
+          </a:effectRef>
+          <a:fontRef idx="minor">
+            <a:schemeClr val="tx1"/>
+          </a:fontRef>
+        </p:style>
+      </p:cxnSp>
+      <p:cxnSp>
+        <p:nvCxnSpPr>
+          <p:cNvPr id="22" name="Elbow Connector 21">
+            <a:extLst>
+              <a:ext uri="{FF2B5EF4-FFF2-40B4-BE49-F238E27FC236}">
+                <a16:creationId xmlns:a16="http://schemas.microsoft.com/office/drawing/2014/main" id="{1844BCE3-DC69-D8D5-7808-65401C3CF094}"/>
+              </a:ext>
+            </a:extLst>
+          </p:cNvPr>
+          <p:cNvCxnSpPr>
+            <a:cxnSpLocks/>
+            <a:stCxn id="8" idx="2"/>
+            <a:endCxn id="9" idx="0"/>
+          </p:cNvCxnSpPr>
+          <p:nvPr/>
+        </p:nvCxnSpPr>
+        <p:spPr>
+          <a:xfrm rot="5400000">
+            <a:off x="6030068" y="3492479"/>
+            <a:ext cx="311388" cy="1"/>
+          </a:xfrm>
+          <a:prstGeom prst="bentConnector3">
+            <a:avLst/>
+          </a:prstGeom>
+          <a:ln w="12700">
+            <a:solidFill>
+              <a:schemeClr val="tx1"/>
+            </a:solidFill>
+            <a:tailEnd type="triangle"/>
+          </a:ln>
+        </p:spPr>
+        <p:style>
+          <a:lnRef idx="1">
+            <a:schemeClr val="accent1"/>
+          </a:lnRef>
+          <a:fillRef idx="0">
+            <a:schemeClr val="accent1"/>
+          </a:fillRef>
+          <a:effectRef idx="0">
+            <a:schemeClr val="accent1"/>
+          </a:effectRef>
+          <a:fontRef idx="minor">
+            <a:schemeClr val="tx1"/>
+          </a:fontRef>
+        </p:style>
+      </p:cxnSp>
+      <p:sp>
+        <p:nvSpPr>
+          <p:cNvPr id="26" name="Oval 25">
+            <a:extLst>
+              <a:ext uri="{FF2B5EF4-FFF2-40B4-BE49-F238E27FC236}">
+                <a16:creationId xmlns:a16="http://schemas.microsoft.com/office/drawing/2014/main" id="{304E546C-EB73-8D35-3EE0-A67443132B7E}"/>
+              </a:ext>
+            </a:extLst>
+          </p:cNvPr>
+          <p:cNvSpPr/>
+          <p:nvPr/>
+        </p:nvSpPr>
+        <p:spPr>
+          <a:xfrm>
+            <a:off x="6005654" y="4421226"/>
+            <a:ext cx="360219" cy="381126"/>
+          </a:xfrm>
+          <a:prstGeom prst="ellipse">
+            <a:avLst/>
+          </a:prstGeom>
+          <a:solidFill>
+            <a:schemeClr val="bg1">
+              <a:lumMod val="50000"/>
+            </a:schemeClr>
+          </a:solidFill>
+          <a:ln>
+            <a:noFill/>
+          </a:ln>
+        </p:spPr>
+        <p:style>
+          <a:lnRef idx="2">
+            <a:schemeClr val="accent1">
+              <a:shade val="15000"/>
+            </a:schemeClr>
+          </a:lnRef>
+          <a:fillRef idx="1">
+            <a:schemeClr val="accent1"/>
+          </a:fillRef>
+          <a:effectRef idx="0">
+            <a:schemeClr val="accent1"/>
+          </a:effectRef>
+          <a:fontRef idx="minor">
+            <a:schemeClr val="lt1"/>
+          </a:fontRef>
+        </p:style>
+        <p:txBody>
+          <a:bodyPr rtlCol="0" anchor="ctr"/>
+          <a:lstStyle/>
+          <a:p>
+            <a:pPr algn="ctr"/>
+            <a:endParaRPr lang="en-NL"/>
+          </a:p>
+        </p:txBody>
+      </p:sp>
+      <p:cxnSp>
+        <p:nvCxnSpPr>
+          <p:cNvPr id="27" name="Elbow Connector 26">
+            <a:extLst>
+              <a:ext uri="{FF2B5EF4-FFF2-40B4-BE49-F238E27FC236}">
+                <a16:creationId xmlns:a16="http://schemas.microsoft.com/office/drawing/2014/main" id="{F2152F14-7AE3-E032-A967-6BC538E12D0E}"/>
+              </a:ext>
+            </a:extLst>
+          </p:cNvPr>
+          <p:cNvCxnSpPr>
+            <a:cxnSpLocks/>
+            <a:stCxn id="9" idx="2"/>
+            <a:endCxn id="26" idx="0"/>
+          </p:cNvCxnSpPr>
+          <p:nvPr/>
+        </p:nvCxnSpPr>
+        <p:spPr>
+          <a:xfrm rot="16200000" flipH="1">
+            <a:off x="6030068" y="4265530"/>
+            <a:ext cx="311388" cy="3"/>
+          </a:xfrm>
+          <a:prstGeom prst="bentConnector3">
+            <a:avLst/>
+          </a:prstGeom>
+          <a:ln w="12700">
+            <a:solidFill>
+              <a:schemeClr val="tx1"/>
+            </a:solidFill>
+            <a:tailEnd type="triangle"/>
+          </a:ln>
+        </p:spPr>
+        <p:style>
+          <a:lnRef idx="1">
+            <a:schemeClr val="accent1"/>
+          </a:lnRef>
+          <a:fillRef idx="0">
+            <a:schemeClr val="accent1"/>
+          </a:fillRef>
+          <a:effectRef idx="0">
+            <a:schemeClr val="accent1"/>
+          </a:effectRef>
+          <a:fontRef idx="minor">
+            <a:schemeClr val="tx1"/>
+          </a:fontRef>
+        </p:style>
+      </p:cxnSp>
+      <p:cxnSp>
+        <p:nvCxnSpPr>
+          <p:cNvPr id="31" name="Elbow Connector 30">
+            <a:extLst>
+              <a:ext uri="{FF2B5EF4-FFF2-40B4-BE49-F238E27FC236}">
+                <a16:creationId xmlns:a16="http://schemas.microsoft.com/office/drawing/2014/main" id="{0D458F91-87C0-C358-7E93-1CC6E09237C1}"/>
+              </a:ext>
+            </a:extLst>
+          </p:cNvPr>
+          <p:cNvCxnSpPr>
+            <a:cxnSpLocks/>
+            <a:stCxn id="7" idx="3"/>
+            <a:endCxn id="10" idx="1"/>
+          </p:cNvCxnSpPr>
+          <p:nvPr/>
+        </p:nvCxnSpPr>
+        <p:spPr>
+          <a:xfrm flipV="1">
+            <a:off x="7063567" y="2330089"/>
+            <a:ext cx="335828" cy="1"/>
+          </a:xfrm>
+          <a:prstGeom prst="bentConnector3">
+            <a:avLst/>
+          </a:prstGeom>
+          <a:ln w="12700">
+            <a:solidFill>
+              <a:schemeClr val="tx1"/>
+            </a:solidFill>
+            <a:tailEnd type="triangle"/>
+          </a:ln>
+        </p:spPr>
+        <p:style>
+          <a:lnRef idx="1">
+            <a:schemeClr val="accent1"/>
+          </a:lnRef>
+          <a:fillRef idx="0">
+            <a:schemeClr val="accent1"/>
+          </a:fillRef>
+          <a:effectRef idx="0">
+            <a:schemeClr val="accent1"/>
+          </a:effectRef>
+          <a:fontRef idx="minor">
+            <a:schemeClr val="tx1"/>
+          </a:fontRef>
+        </p:style>
+      </p:cxnSp>
+      <p:cxnSp>
+        <p:nvCxnSpPr>
+          <p:cNvPr id="34" name="Elbow Connector 33">
+            <a:extLst>
+              <a:ext uri="{FF2B5EF4-FFF2-40B4-BE49-F238E27FC236}">
+                <a16:creationId xmlns:a16="http://schemas.microsoft.com/office/drawing/2014/main" id="{975DC2A2-32F8-2390-B2E8-3B56E65C4267}"/>
+              </a:ext>
+            </a:extLst>
+          </p:cNvPr>
+          <p:cNvCxnSpPr>
+            <a:cxnSpLocks/>
+            <a:stCxn id="8" idx="3"/>
+            <a:endCxn id="10" idx="2"/>
+          </p:cNvCxnSpPr>
+          <p:nvPr/>
+        </p:nvCxnSpPr>
+        <p:spPr>
+          <a:xfrm flipV="1">
+            <a:off x="6557017" y="2560921"/>
+            <a:ext cx="1384354" cy="545032"/>
+          </a:xfrm>
+          <a:prstGeom prst="bentConnector2">
+            <a:avLst/>
+          </a:prstGeom>
+          <a:ln w="12700">
+            <a:solidFill>
+              <a:schemeClr val="tx1"/>
+            </a:solidFill>
+            <a:tailEnd type="triangle"/>
+          </a:ln>
+        </p:spPr>
+        <p:style>
+          <a:lnRef idx="1">
+            <a:schemeClr val="accent1"/>
+          </a:lnRef>
+          <a:fillRef idx="0">
+            <a:schemeClr val="accent1"/>
+          </a:fillRef>
+          <a:effectRef idx="0">
+            <a:schemeClr val="accent1"/>
+          </a:effectRef>
+          <a:fontRef idx="minor">
+            <a:schemeClr val="tx1"/>
+          </a:fontRef>
+        </p:style>
+      </p:cxnSp>
+      <p:sp>
+        <p:nvSpPr>
+          <p:cNvPr id="39" name="TextBox 38">
+            <a:extLst>
+              <a:ext uri="{FF2B5EF4-FFF2-40B4-BE49-F238E27FC236}">
+                <a16:creationId xmlns:a16="http://schemas.microsoft.com/office/drawing/2014/main" id="{F3082EAF-5BB0-324A-47C8-96859537E044}"/>
+              </a:ext>
+            </a:extLst>
+          </p:cNvPr>
+          <p:cNvSpPr txBox="1"/>
+          <p:nvPr/>
+        </p:nvSpPr>
+        <p:spPr>
+          <a:xfrm>
+            <a:off x="4094295" y="4892751"/>
+            <a:ext cx="4182929" cy="1015663"/>
+          </a:xfrm>
+          <a:prstGeom prst="rect">
+            <a:avLst/>
+          </a:prstGeom>
+          <a:noFill/>
+        </p:spPr>
+        <p:txBody>
+          <a:bodyPr wrap="square" rtlCol="0">
+            <a:spAutoFit/>
+          </a:bodyPr>
+          <a:lstStyle/>
+          <a:p>
+            <a:pPr algn="ctr"/>
+            <a:r>
+              <a:rPr lang="en-NL" sz="2000" dirty="0"/>
+              <a:t>Control Flow Graph (CFG) of the statement to the left. From here execution paths can be generated.</a:t>
+            </a:r>
+          </a:p>
+        </p:txBody>
+      </p:sp>
+      <p:sp>
+        <p:nvSpPr>
+          <p:cNvPr id="40" name="Right Arrow 39">
+            <a:extLst>
+              <a:ext uri="{FF2B5EF4-FFF2-40B4-BE49-F238E27FC236}">
+                <a16:creationId xmlns:a16="http://schemas.microsoft.com/office/drawing/2014/main" id="{6157B6FB-0903-CA04-FE1A-AD7FFB3460D8}"/>
+              </a:ext>
+            </a:extLst>
+          </p:cNvPr>
+          <p:cNvSpPr/>
+          <p:nvPr/>
+        </p:nvSpPr>
+        <p:spPr>
+          <a:xfrm>
+            <a:off x="4247211" y="2330088"/>
+            <a:ext cx="724919" cy="609647"/>
+          </a:xfrm>
+          <a:prstGeom prst="rightArrow">
+            <a:avLst/>
+          </a:prstGeom>
+          <a:solidFill>
+            <a:schemeClr val="accent2">
+              <a:lumMod val="60000"/>
+              <a:lumOff val="40000"/>
+            </a:schemeClr>
+          </a:solidFill>
+        </p:spPr>
+        <p:style>
+          <a:lnRef idx="2">
+            <a:schemeClr val="accent1">
+              <a:shade val="15000"/>
+            </a:schemeClr>
+          </a:lnRef>
+          <a:fillRef idx="1">
+            <a:schemeClr val="accent1"/>
+          </a:fillRef>
+          <a:effectRef idx="0">
+            <a:schemeClr val="accent1"/>
+          </a:effectRef>
+          <a:fontRef idx="minor">
+            <a:schemeClr val="lt1"/>
+          </a:fontRef>
+        </p:style>
+        <p:txBody>
+          <a:bodyPr rtlCol="0" anchor="ctr"/>
+          <a:lstStyle/>
+          <a:p>
+            <a:pPr algn="ctr"/>
+            <a:endParaRPr lang="en-NL"/>
+          </a:p>
+        </p:txBody>
+      </p:sp>
     </p:spTree>
     <p:extLst>
       <p:ext uri="{BB962C8B-B14F-4D97-AF65-F5344CB8AC3E}">
-        <p14:creationId xmlns:p14="http://schemas.microsoft.com/office/powerpoint/2010/main" val="56591070"/>
+        <p14:creationId xmlns:p14="http://schemas.microsoft.com/office/powerpoint/2010/main" val="644109243"/>
       </p:ext>
     </p:extLst>
   </p:cSld>
@@ -41892,645 +42134,6 @@
             <p:ph type="title"/>
           </p:nvPr>
         </p:nvSpPr>
-        <p:spPr/>
-        <p:txBody>
-          <a:bodyPr/>
-          <a:lstStyle/>
-          <a:p>
-            <a:r>
-              <a:rPr lang="en-US" dirty="0"/>
-              <a:t>Approach 2</a:t>
-            </a:r>
-          </a:p>
-        </p:txBody>
-      </p:sp>
-      <p:sp>
-        <p:nvSpPr>
-          <p:cNvPr id="3" name="Content Placeholder 2"/>
-          <p:cNvSpPr>
-            <a:spLocks noGrp="1"/>
-          </p:cNvSpPr>
-          <p:nvPr>
-            <p:ph idx="1"/>
-          </p:nvPr>
-        </p:nvSpPr>
-        <p:spPr>
-          <a:xfrm>
-            <a:off x="685800" y="1383957"/>
-            <a:ext cx="7772400" cy="5109440"/>
-          </a:xfrm>
-        </p:spPr>
-        <p:txBody>
-          <a:bodyPr>
-            <a:normAutofit/>
-          </a:bodyPr>
-          <a:lstStyle/>
-          <a:p>
-            <a:r>
-              <a:rPr lang="en-US" dirty="0"/>
-              <a:t>Extend the post-condition from a single predicate to a pair of predicate:</a:t>
-            </a:r>
-            <a:br>
-              <a:rPr lang="en-US" dirty="0"/>
-            </a:br>
-            <a:br>
-              <a:rPr lang="en-US" dirty="0"/>
-            </a:br>
-            <a:r>
-              <a:rPr lang="en-US" dirty="0"/>
-              <a:t>{P}  S {Q,R}  where Q describes the expectation when S terminates normally, and R the expectation when S terminates by exception.</a:t>
-            </a:r>
-          </a:p>
-          <a:p>
-            <a:r>
-              <a:rPr lang="en-US" b="1" dirty="0" err="1">
-                <a:solidFill>
-                  <a:srgbClr val="FF0000"/>
-                </a:solidFill>
-              </a:rPr>
-              <a:t>wlp</a:t>
-            </a:r>
-            <a:r>
-              <a:rPr lang="en-US" dirty="0">
-                <a:solidFill>
-                  <a:srgbClr val="FF0000"/>
-                </a:solidFill>
-              </a:rPr>
-              <a:t> </a:t>
-            </a:r>
-            <a:r>
-              <a:rPr lang="en-US" dirty="0"/>
-              <a:t>(</a:t>
-            </a:r>
-            <a:r>
-              <a:rPr lang="en-US" i="1" dirty="0"/>
-              <a:t>x</a:t>
-            </a:r>
-            <a:r>
-              <a:rPr lang="en-US" dirty="0"/>
-              <a:t> := </a:t>
-            </a:r>
-            <a:r>
-              <a:rPr lang="en-US" i="1" dirty="0"/>
-              <a:t>e</a:t>
-            </a:r>
-            <a:r>
-              <a:rPr lang="en-US" dirty="0"/>
-              <a:t>) (</a:t>
-            </a:r>
-            <a:r>
-              <a:rPr lang="en-US" i="1" dirty="0"/>
-              <a:t>Q,R</a:t>
-            </a:r>
-            <a:r>
-              <a:rPr lang="en-US" dirty="0"/>
-              <a:t>) =  </a:t>
-            </a:r>
-            <a:r>
-              <a:rPr lang="en-US" i="1" dirty="0"/>
-              <a:t>Q</a:t>
-            </a:r>
-            <a:r>
-              <a:rPr lang="en-US" dirty="0"/>
-              <a:t>[</a:t>
-            </a:r>
-            <a:r>
-              <a:rPr lang="en-US" i="1" dirty="0"/>
-              <a:t>e/x</a:t>
-            </a:r>
-            <a:r>
-              <a:rPr lang="en-US" dirty="0"/>
-              <a:t>]     </a:t>
-            </a:r>
-            <a:r>
-              <a:rPr lang="en-US" sz="1400" dirty="0"/>
-              <a:t>-- assuming e does not throw an exception.</a:t>
-            </a:r>
-          </a:p>
-          <a:p>
-            <a:r>
-              <a:rPr lang="en-US" b="1" dirty="0" err="1">
-                <a:solidFill>
-                  <a:srgbClr val="FF0000"/>
-                </a:solidFill>
-              </a:rPr>
-              <a:t>wlp</a:t>
-            </a:r>
-            <a:r>
-              <a:rPr lang="en-US" b="1" dirty="0">
-                <a:solidFill>
-                  <a:srgbClr val="FF0000"/>
-                </a:solidFill>
-              </a:rPr>
-              <a:t> </a:t>
-            </a:r>
-            <a:r>
-              <a:rPr lang="en-US" b="1" dirty="0"/>
-              <a:t>raise</a:t>
-            </a:r>
-            <a:r>
-              <a:rPr lang="en-US" dirty="0"/>
-              <a:t> (</a:t>
-            </a:r>
-            <a:r>
-              <a:rPr lang="en-US" i="1" dirty="0"/>
-              <a:t>Q,R</a:t>
-            </a:r>
-            <a:r>
-              <a:rPr lang="en-US" dirty="0"/>
-              <a:t>)     =  </a:t>
-            </a:r>
-            <a:r>
-              <a:rPr lang="en-US" i="1" dirty="0"/>
-              <a:t>R</a:t>
-            </a:r>
-          </a:p>
-          <a:p>
-            <a:r>
-              <a:rPr lang="en-US" b="1" dirty="0" err="1">
-                <a:solidFill>
-                  <a:srgbClr val="FF0000"/>
-                </a:solidFill>
-              </a:rPr>
-              <a:t>wlp</a:t>
-            </a:r>
-            <a:r>
-              <a:rPr lang="en-US" dirty="0">
-                <a:solidFill>
-                  <a:srgbClr val="FF0000"/>
-                </a:solidFill>
-              </a:rPr>
-              <a:t> </a:t>
-            </a:r>
-            <a:r>
-              <a:rPr lang="en-US" dirty="0"/>
-              <a:t>(</a:t>
-            </a:r>
-            <a:r>
-              <a:rPr lang="en-US" i="1" dirty="0"/>
-              <a:t>S</a:t>
-            </a:r>
-            <a:r>
-              <a:rPr lang="en-US" baseline="-25000" dirty="0"/>
-              <a:t>1</a:t>
-            </a:r>
-            <a:r>
-              <a:rPr lang="en-US" dirty="0"/>
-              <a:t> ; </a:t>
-            </a:r>
-            <a:r>
-              <a:rPr lang="en-US" i="1" dirty="0"/>
-              <a:t>S</a:t>
-            </a:r>
-            <a:r>
-              <a:rPr lang="en-US" baseline="-25000" dirty="0"/>
-              <a:t>2</a:t>
-            </a:r>
-            <a:r>
-              <a:rPr lang="en-US" dirty="0"/>
-              <a:t>) (</a:t>
-            </a:r>
-            <a:r>
-              <a:rPr lang="en-US" i="1" dirty="0"/>
-              <a:t>Q,R</a:t>
-            </a:r>
-            <a:r>
-              <a:rPr lang="en-US" dirty="0"/>
-              <a:t>) =  </a:t>
-            </a:r>
-            <a:r>
-              <a:rPr lang="en-US" b="1" dirty="0" err="1">
-                <a:solidFill>
-                  <a:srgbClr val="FF0000"/>
-                </a:solidFill>
-              </a:rPr>
-              <a:t>wlp</a:t>
-            </a:r>
-            <a:r>
-              <a:rPr lang="en-US" dirty="0"/>
-              <a:t> </a:t>
-            </a:r>
-            <a:r>
-              <a:rPr lang="en-US" i="1" dirty="0"/>
-              <a:t>S</a:t>
-            </a:r>
-            <a:r>
-              <a:rPr lang="en-US" baseline="-25000" dirty="0"/>
-              <a:t>1</a:t>
-            </a:r>
-            <a:r>
-              <a:rPr lang="en-US" dirty="0"/>
-              <a:t> (</a:t>
-            </a:r>
-            <a:r>
-              <a:rPr lang="en-US" b="1" dirty="0" err="1">
-                <a:solidFill>
-                  <a:srgbClr val="FF0000"/>
-                </a:solidFill>
-              </a:rPr>
-              <a:t>wlp</a:t>
-            </a:r>
-            <a:r>
-              <a:rPr lang="en-US" dirty="0"/>
-              <a:t> </a:t>
-            </a:r>
-            <a:r>
-              <a:rPr lang="en-US" i="1" dirty="0"/>
-              <a:t>S</a:t>
-            </a:r>
-            <a:r>
-              <a:rPr lang="en-US" baseline="-25000" dirty="0"/>
-              <a:t>2</a:t>
-            </a:r>
-            <a:r>
-              <a:rPr lang="en-US" dirty="0"/>
-              <a:t> (</a:t>
-            </a:r>
-            <a:r>
-              <a:rPr lang="en-US" i="1" dirty="0"/>
-              <a:t>Q</a:t>
-            </a:r>
-            <a:r>
-              <a:rPr lang="en-US" dirty="0"/>
-              <a:t>,</a:t>
-            </a:r>
-            <a:r>
-              <a:rPr lang="en-US" i="1" dirty="0"/>
-              <a:t>R</a:t>
-            </a:r>
-            <a:r>
-              <a:rPr lang="en-US" dirty="0"/>
-              <a:t>), </a:t>
-            </a:r>
-            <a:r>
-              <a:rPr lang="en-US" i="1" dirty="0"/>
-              <a:t>R</a:t>
-            </a:r>
-            <a:r>
-              <a:rPr lang="en-US" dirty="0"/>
-              <a:t>)</a:t>
-            </a:r>
-          </a:p>
-          <a:p>
-            <a:r>
-              <a:rPr lang="en-US" b="1" dirty="0" err="1">
-                <a:solidFill>
-                  <a:srgbClr val="FF0000"/>
-                </a:solidFill>
-              </a:rPr>
-              <a:t>wlp</a:t>
-            </a:r>
-            <a:r>
-              <a:rPr lang="en-US" dirty="0">
-                <a:solidFill>
-                  <a:srgbClr val="FF0000"/>
-                </a:solidFill>
-              </a:rPr>
-              <a:t> </a:t>
-            </a:r>
-            <a:r>
-              <a:rPr lang="en-US" dirty="0"/>
-              <a:t>(</a:t>
-            </a:r>
-            <a:r>
-              <a:rPr lang="en-US" i="1" dirty="0"/>
-              <a:t>S</a:t>
-            </a:r>
-            <a:r>
-              <a:rPr lang="en-US" dirty="0"/>
-              <a:t> ! </a:t>
-            </a:r>
-            <a:r>
-              <a:rPr lang="en-US" i="1" dirty="0"/>
-              <a:t>H</a:t>
-            </a:r>
-            <a:r>
-              <a:rPr lang="en-US" dirty="0"/>
-              <a:t>) (</a:t>
-            </a:r>
-            <a:r>
-              <a:rPr lang="en-US" i="1" dirty="0"/>
-              <a:t>Q,R</a:t>
-            </a:r>
-            <a:r>
-              <a:rPr lang="en-US" dirty="0"/>
-              <a:t>)   =  </a:t>
-            </a:r>
-            <a:r>
-              <a:rPr lang="en-US" b="1" dirty="0" err="1">
-                <a:solidFill>
-                  <a:srgbClr val="FF0000"/>
-                </a:solidFill>
-              </a:rPr>
-              <a:t>wlp</a:t>
-            </a:r>
-            <a:r>
-              <a:rPr lang="en-US" dirty="0"/>
-              <a:t>  S  (</a:t>
-            </a:r>
-            <a:r>
-              <a:rPr lang="en-US" i="1" dirty="0"/>
-              <a:t>Q</a:t>
-            </a:r>
-            <a:r>
-              <a:rPr lang="en-US" dirty="0"/>
-              <a:t> ,  </a:t>
-            </a:r>
-            <a:r>
-              <a:rPr lang="en-US" b="1" dirty="0" err="1">
-                <a:solidFill>
-                  <a:srgbClr val="FF0000"/>
-                </a:solidFill>
-              </a:rPr>
-              <a:t>wlp</a:t>
-            </a:r>
-            <a:r>
-              <a:rPr lang="en-US" dirty="0"/>
-              <a:t>  </a:t>
-            </a:r>
-            <a:r>
-              <a:rPr lang="en-US" i="1" dirty="0"/>
-              <a:t>H</a:t>
-            </a:r>
-            <a:r>
-              <a:rPr lang="en-US" dirty="0"/>
-              <a:t>  (</a:t>
-            </a:r>
-            <a:r>
-              <a:rPr lang="en-US" i="1" dirty="0"/>
-              <a:t>Q,R</a:t>
-            </a:r>
-            <a:r>
-              <a:rPr lang="en-US" dirty="0"/>
-              <a:t>))</a:t>
-            </a:r>
-          </a:p>
-          <a:p>
-            <a:r>
-              <a:rPr lang="en-US" dirty="0"/>
-              <a:t>This avoids blow up that we saw in Approach-1, but on the other hand </a:t>
-            </a:r>
-            <a:r>
-              <a:rPr lang="en-US" dirty="0" err="1"/>
-              <a:t>wlp</a:t>
-            </a:r>
-            <a:r>
-              <a:rPr lang="en-US" dirty="0"/>
-              <a:t> becomes more complicated.</a:t>
-            </a:r>
-          </a:p>
-        </p:txBody>
-      </p:sp>
-      <p:sp>
-        <p:nvSpPr>
-          <p:cNvPr id="4" name="Slide Number Placeholder 3"/>
-          <p:cNvSpPr>
-            <a:spLocks noGrp="1"/>
-          </p:cNvSpPr>
-          <p:nvPr>
-            <p:ph type="sldNum" sz="quarter" idx="12"/>
-          </p:nvPr>
-        </p:nvSpPr>
-        <p:spPr/>
-        <p:txBody>
-          <a:bodyPr/>
-          <a:lstStyle/>
-          <a:p>
-            <a:pPr>
-              <a:defRPr/>
-            </a:pPr>
-            <a:fld id="{58A332FB-769C-4CBB-BDDE-0DC26211CC04}" type="slidenum">
-              <a:rPr lang="en-US" smtClean="0"/>
-              <a:pPr>
-                <a:defRPr/>
-              </a:pPr>
-              <a:t>70</a:t>
-            </a:fld>
-            <a:endParaRPr lang="en-US"/>
-          </a:p>
-        </p:txBody>
-      </p:sp>
-    </p:spTree>
-    <p:extLst>
-      <p:ext uri="{BB962C8B-B14F-4D97-AF65-F5344CB8AC3E}">
-        <p14:creationId xmlns:p14="http://schemas.microsoft.com/office/powerpoint/2010/main" val="199937732"/>
-      </p:ext>
-    </p:extLst>
-  </p:cSld>
-  <p:clrMapOvr>
-    <a:masterClrMapping/>
-  </p:clrMapOvr>
-</p:sld>
-</file>
-
-<file path=ppt/slides/slide71.xml><?xml version="1.0" encoding="utf-8"?>
-<p:sld xmlns:a="http://schemas.openxmlformats.org/drawingml/2006/main" xmlns:r="http://schemas.openxmlformats.org/officeDocument/2006/relationships" xmlns:p="http://schemas.openxmlformats.org/presentationml/2006/main">
-  <p:cSld>
-    <p:spTree>
-      <p:nvGrpSpPr>
-        <p:cNvPr id="1" name=""/>
-        <p:cNvGrpSpPr/>
-        <p:nvPr/>
-      </p:nvGrpSpPr>
-      <p:grpSpPr>
-        <a:xfrm>
-          <a:off x="0" y="0"/>
-          <a:ext cx="0" cy="0"/>
-          <a:chOff x="0" y="0"/>
-          <a:chExt cx="0" cy="0"/>
-        </a:xfrm>
-      </p:grpSpPr>
-      <p:sp>
-        <p:nvSpPr>
-          <p:cNvPr id="2" name="Title 1">
-            <a:extLst>
-              <a:ext uri="{FF2B5EF4-FFF2-40B4-BE49-F238E27FC236}">
-                <a16:creationId xmlns:a16="http://schemas.microsoft.com/office/drawing/2014/main" id="{EF29DA16-EC1E-7D41-8847-2ECBA4A7775A}"/>
-              </a:ext>
-            </a:extLst>
-          </p:cNvPr>
-          <p:cNvSpPr>
-            <a:spLocks noGrp="1"/>
-          </p:cNvSpPr>
-          <p:nvPr>
-            <p:ph type="title"/>
-          </p:nvPr>
-        </p:nvSpPr>
-        <p:spPr/>
-        <p:txBody>
-          <a:bodyPr/>
-          <a:lstStyle/>
-          <a:p>
-            <a:r>
-              <a:rPr lang="en-US" dirty="0"/>
-              <a:t>exception</a:t>
-            </a:r>
-          </a:p>
-        </p:txBody>
-      </p:sp>
-      <p:sp>
-        <p:nvSpPr>
-          <p:cNvPr id="3" name="Content Placeholder 2">
-            <a:extLst>
-              <a:ext uri="{FF2B5EF4-FFF2-40B4-BE49-F238E27FC236}">
-                <a16:creationId xmlns:a16="http://schemas.microsoft.com/office/drawing/2014/main" id="{21C60239-2BC9-0843-BA8D-FA47D0CA0809}"/>
-              </a:ext>
-            </a:extLst>
-          </p:cNvPr>
-          <p:cNvSpPr>
-            <a:spLocks noGrp="1"/>
-          </p:cNvSpPr>
-          <p:nvPr>
-            <p:ph idx="1"/>
-          </p:nvPr>
-        </p:nvSpPr>
-        <p:spPr/>
-        <p:txBody>
-          <a:bodyPr/>
-          <a:lstStyle/>
-          <a:p>
-            <a:r>
-              <a:rPr lang="en-US" dirty="0"/>
-              <a:t>Approach 1: </a:t>
-            </a:r>
-          </a:p>
-          <a:p>
-            <a:pPr lvl="1"/>
-            <a:r>
-              <a:rPr lang="en-US" dirty="0" err="1"/>
-              <a:t>wlp</a:t>
-            </a:r>
-            <a:r>
-              <a:rPr lang="en-US" dirty="0"/>
-              <a:t>-rules are still the same</a:t>
-            </a:r>
-          </a:p>
-          <a:p>
-            <a:pPr lvl="1"/>
-            <a:r>
-              <a:rPr lang="en-US" dirty="0"/>
-              <a:t>But it leads to blow up, unless we do the optimization.</a:t>
-            </a:r>
-          </a:p>
-          <a:p>
-            <a:pPr lvl="1"/>
-            <a:endParaRPr lang="en-US" dirty="0"/>
-          </a:p>
-          <a:p>
-            <a:r>
-              <a:rPr lang="en-US" dirty="0"/>
-              <a:t>Approach 2:</a:t>
-            </a:r>
-          </a:p>
-          <a:p>
-            <a:pPr lvl="1"/>
-            <a:r>
-              <a:rPr lang="en-US" dirty="0"/>
-              <a:t>does not blow up, but we need to keep track of two post-conditions.</a:t>
-            </a:r>
-          </a:p>
-          <a:p>
-            <a:pPr lvl="1"/>
-            <a:endParaRPr lang="en-US" dirty="0"/>
-          </a:p>
-          <a:p>
-            <a:r>
-              <a:rPr lang="en-US" dirty="0"/>
-              <a:t>To consider: using a control flow graph.</a:t>
-            </a:r>
-          </a:p>
-          <a:p>
-            <a:pPr lvl="1"/>
-            <a:r>
-              <a:rPr lang="en-US" dirty="0"/>
-              <a:t>But </a:t>
-            </a:r>
-            <a:r>
-              <a:rPr lang="en-US" dirty="0" err="1"/>
-              <a:t>wlp</a:t>
-            </a:r>
-            <a:r>
-              <a:rPr lang="en-US" dirty="0"/>
-              <a:t> is then no longer syntax driven.</a:t>
-            </a:r>
-          </a:p>
-        </p:txBody>
-      </p:sp>
-      <p:sp>
-        <p:nvSpPr>
-          <p:cNvPr id="4" name="Slide Number Placeholder 3">
-            <a:extLst>
-              <a:ext uri="{FF2B5EF4-FFF2-40B4-BE49-F238E27FC236}">
-                <a16:creationId xmlns:a16="http://schemas.microsoft.com/office/drawing/2014/main" id="{B8365CC2-5E50-1F40-B607-A34A9715C005}"/>
-              </a:ext>
-            </a:extLst>
-          </p:cNvPr>
-          <p:cNvSpPr>
-            <a:spLocks noGrp="1"/>
-          </p:cNvSpPr>
-          <p:nvPr>
-            <p:ph type="sldNum" sz="quarter" idx="12"/>
-          </p:nvPr>
-        </p:nvSpPr>
-        <p:spPr/>
-        <p:txBody>
-          <a:bodyPr/>
-          <a:lstStyle/>
-          <a:p>
-            <a:pPr>
-              <a:defRPr/>
-            </a:pPr>
-            <a:fld id="{58A332FB-769C-4CBB-BDDE-0DC26211CC04}" type="slidenum">
-              <a:rPr lang="en-US" smtClean="0"/>
-              <a:pPr>
-                <a:defRPr/>
-              </a:pPr>
-              <a:t>71</a:t>
-            </a:fld>
-            <a:endParaRPr lang="en-US"/>
-          </a:p>
-        </p:txBody>
-      </p:sp>
-    </p:spTree>
-    <p:extLst>
-      <p:ext uri="{BB962C8B-B14F-4D97-AF65-F5344CB8AC3E}">
-        <p14:creationId xmlns:p14="http://schemas.microsoft.com/office/powerpoint/2010/main" val="1424081662"/>
-      </p:ext>
-    </p:extLst>
-  </p:cSld>
-  <p:clrMapOvr>
-    <a:masterClrMapping/>
-  </p:clrMapOvr>
-</p:sld>
-</file>
-
-<file path=ppt/slides/slide72.xml><?xml version="1.0" encoding="utf-8"?>
-<p:sld xmlns:a="http://schemas.openxmlformats.org/drawingml/2006/main" xmlns:r="http://schemas.openxmlformats.org/officeDocument/2006/relationships" xmlns:p="http://schemas.openxmlformats.org/presentationml/2006/main">
-  <p:cSld>
-    <p:spTree>
-      <p:nvGrpSpPr>
-        <p:cNvPr id="1" name=""/>
-        <p:cNvGrpSpPr/>
-        <p:nvPr/>
-      </p:nvGrpSpPr>
-      <p:grpSpPr>
-        <a:xfrm>
-          <a:off x="0" y="0"/>
-          <a:ext cx="0" cy="0"/>
-          <a:chOff x="0" y="0"/>
-          <a:chExt cx="0" cy="0"/>
-        </a:xfrm>
-      </p:grpSpPr>
-      <p:sp>
-        <p:nvSpPr>
-          <p:cNvPr id="2" name="Title 1"/>
-          <p:cNvSpPr>
-            <a:spLocks noGrp="1"/>
-          </p:cNvSpPr>
-          <p:nvPr>
-            <p:ph type="title"/>
-          </p:nvPr>
-        </p:nvSpPr>
         <p:spPr>
           <a:xfrm>
             <a:off x="500034" y="226512"/>
@@ -42653,7 +42256,7 @@
               <a:pPr>
                 <a:defRPr/>
               </a:pPr>
-              <a:t>72</a:t>
+              <a:t>70</a:t>
             </a:fld>
             <a:endParaRPr lang="en-US"/>
           </a:p>

</xml_diff>

<commit_message>
fixing some mistakes in slides
</commit_message>
<xml_diff>
--- a/slides/PV_hoare.pptx
+++ b/slides/PV_hoare.pptx
@@ -40555,20 +40555,6 @@
             <a:r>
               <a:rPr lang="en-US" dirty="0"/>
               <a:t>))</a:t>
-            </a:r>
-          </a:p>
-          <a:p>
-            <a:r>
-              <a:rPr lang="en-US" dirty="0"/>
-              <a:t>This avoids blow up that we saw in Approach-1, but on the other hand </a:t>
-            </a:r>
-            <a:r>
-              <a:rPr lang="en-US" dirty="0" err="1"/>
-              <a:t>wlp</a:t>
-            </a:r>
-            <a:r>
-              <a:rPr lang="en-US" dirty="0"/>
-              <a:t> becomes more complicated.</a:t>
             </a:r>
           </a:p>
         </p:txBody>

</xml_diff>